<commit_message>
Improve DSI defense presentation with AGAUR functional case
</commit_message>
<xml_diff>
--- a/doc/presentations/defensa-placa-permanent-dsi-ports-sortida-hexagonal/output/defensa-dsi-ports-sortida-hexagonal.pptx
+++ b/doc/presentations/defensa-placa-permanent-dsi-ports-sortida-hexagonal/output/defensa-dsi-ports-sortida-hexagonal.pptx
@@ -15,6 +15,7 @@
     <p:sldId id="263" r:id="rId9"/>
     <p:sldId id="264" r:id="rId10"/>
     <p:sldId id="265" r:id="rId11"/>
+    <p:sldId id="266" r:id="rId12"/>
   </p:sldIdLst>
   <p:sldSz cx="12192000" cy="6858000"/>
   <p:notesSz cx="6858000" cy="9144000"/>
@@ -311,7 +312,7 @@
           <a:p>
             <a:fld id="{5BCAD085-E8A6-8845-BD4E-CB4CCA059FC4}" type="datetimeFigureOut">
               <a:rPr lang="en-US" smtClean="0"/>
-              <a:t>6/28/26</a:t>
+              <a:t>6/29/26</a:t>
             </a:fld>
             <a:endParaRPr lang="en-US"/>
           </a:p>
@@ -479,7 +480,7 @@
           <a:p>
             <a:fld id="{5BCAD085-E8A6-8845-BD4E-CB4CCA059FC4}" type="datetimeFigureOut">
               <a:rPr lang="en-US" smtClean="0"/>
-              <a:t>6/28/26</a:t>
+              <a:t>6/29/26</a:t>
             </a:fld>
             <a:endParaRPr lang="en-US"/>
           </a:p>
@@ -657,7 +658,7 @@
           <a:p>
             <a:fld id="{5BCAD085-E8A6-8845-BD4E-CB4CCA059FC4}" type="datetimeFigureOut">
               <a:rPr lang="en-US" smtClean="0"/>
-              <a:t>6/28/26</a:t>
+              <a:t>6/29/26</a:t>
             </a:fld>
             <a:endParaRPr lang="en-US"/>
           </a:p>
@@ -825,7 +826,7 @@
           <a:p>
             <a:fld id="{5BCAD085-E8A6-8845-BD4E-CB4CCA059FC4}" type="datetimeFigureOut">
               <a:rPr lang="en-US" smtClean="0"/>
-              <a:t>6/28/26</a:t>
+              <a:t>6/29/26</a:t>
             </a:fld>
             <a:endParaRPr lang="en-US"/>
           </a:p>
@@ -1070,7 +1071,7 @@
           <a:p>
             <a:fld id="{5BCAD085-E8A6-8845-BD4E-CB4CCA059FC4}" type="datetimeFigureOut">
               <a:rPr lang="en-US" smtClean="0"/>
-              <a:t>6/28/26</a:t>
+              <a:t>6/29/26</a:t>
             </a:fld>
             <a:endParaRPr lang="en-US"/>
           </a:p>
@@ -1355,7 +1356,7 @@
           <a:p>
             <a:fld id="{5BCAD085-E8A6-8845-BD4E-CB4CCA059FC4}" type="datetimeFigureOut">
               <a:rPr lang="en-US" smtClean="0"/>
-              <a:t>6/28/26</a:t>
+              <a:t>6/29/26</a:t>
             </a:fld>
             <a:endParaRPr lang="en-US"/>
           </a:p>
@@ -1774,7 +1775,7 @@
           <a:p>
             <a:fld id="{5BCAD085-E8A6-8845-BD4E-CB4CCA059FC4}" type="datetimeFigureOut">
               <a:rPr lang="en-US" smtClean="0"/>
-              <a:t>6/28/26</a:t>
+              <a:t>6/29/26</a:t>
             </a:fld>
             <a:endParaRPr lang="en-US"/>
           </a:p>
@@ -1891,7 +1892,7 @@
           <a:p>
             <a:fld id="{5BCAD085-E8A6-8845-BD4E-CB4CCA059FC4}" type="datetimeFigureOut">
               <a:rPr lang="en-US" smtClean="0"/>
-              <a:t>6/28/26</a:t>
+              <a:t>6/29/26</a:t>
             </a:fld>
             <a:endParaRPr lang="en-US"/>
           </a:p>
@@ -1986,7 +1987,7 @@
           <a:p>
             <a:fld id="{5BCAD085-E8A6-8845-BD4E-CB4CCA059FC4}" type="datetimeFigureOut">
               <a:rPr lang="en-US" smtClean="0"/>
-              <a:t>6/28/26</a:t>
+              <a:t>6/29/26</a:t>
             </a:fld>
             <a:endParaRPr lang="en-US"/>
           </a:p>
@@ -2261,7 +2262,7 @@
           <a:p>
             <a:fld id="{5BCAD085-E8A6-8845-BD4E-CB4CCA059FC4}" type="datetimeFigureOut">
               <a:rPr lang="en-US" smtClean="0"/>
-              <a:t>6/28/26</a:t>
+              <a:t>6/29/26</a:t>
             </a:fld>
             <a:endParaRPr lang="en-US"/>
           </a:p>
@@ -2513,7 +2514,7 @@
           <a:p>
             <a:fld id="{5BCAD085-E8A6-8845-BD4E-CB4CCA059FC4}" type="datetimeFigureOut">
               <a:rPr lang="en-US" smtClean="0"/>
-              <a:t>6/28/26</a:t>
+              <a:t>6/29/26</a:t>
             </a:fld>
             <a:endParaRPr lang="en-US"/>
           </a:p>
@@ -2724,7 +2725,7 @@
           <a:p>
             <a:fld id="{5BCAD085-E8A6-8845-BD4E-CB4CCA059FC4}" type="datetimeFigureOut">
               <a:rPr lang="en-US" smtClean="0"/>
-              <a:t>6/28/26</a:t>
+              <a:t>6/29/26</a:t>
             </a:fld>
             <a:endParaRPr lang="en-US"/>
           </a:p>
@@ -3147,76 +3148,13 @@
           <a:p>
             <a:pPr algn="l"/>
             <a:r>
-              <a:rPr sz="3200" b="1" dirty="0" err="1">
+              <a:rPr sz="3200" b="1">
                 <a:solidFill>
                   <a:srgbClr val="192D3E"/>
                 </a:solidFill>
                 <a:latin typeface="Arial"/>
               </a:rPr>
-              <a:t>Disseny</a:t>
-            </a:r>
-            <a:r>
-              <a:rPr sz="3200" b="1" dirty="0">
-                <a:solidFill>
-                  <a:srgbClr val="192D3E"/>
-                </a:solidFill>
-                <a:latin typeface="Arial"/>
-              </a:rPr>
-              <a:t> de ports de </a:t>
-            </a:r>
-            <a:r>
-              <a:rPr sz="3200" b="1" dirty="0" err="1">
-                <a:solidFill>
-                  <a:srgbClr val="192D3E"/>
-                </a:solidFill>
-                <a:latin typeface="Arial"/>
-              </a:rPr>
-              <a:t>sortida</a:t>
-            </a:r>
-            <a:r>
-              <a:rPr sz="3200" b="1" dirty="0">
-                <a:solidFill>
-                  <a:srgbClr val="192D3E"/>
-                </a:solidFill>
-                <a:latin typeface="Arial"/>
-              </a:rPr>
-              <a:t> </a:t>
-            </a:r>
-            <a:r>
-              <a:rPr sz="3200" b="1" dirty="0" err="1">
-                <a:solidFill>
-                  <a:srgbClr val="192D3E"/>
-                </a:solidFill>
-                <a:latin typeface="Arial"/>
-              </a:rPr>
-              <a:t>en</a:t>
-            </a:r>
-            <a:r>
-              <a:rPr sz="3200" b="1" dirty="0">
-                <a:solidFill>
-                  <a:srgbClr val="192D3E"/>
-                </a:solidFill>
-                <a:latin typeface="Arial"/>
-              </a:rPr>
-              <a:t> </a:t>
-            </a:r>
-            <a:r>
-              <a:rPr sz="3200" b="1" dirty="0" err="1">
-                <a:solidFill>
-                  <a:srgbClr val="192D3E"/>
-                </a:solidFill>
-                <a:latin typeface="Arial"/>
-              </a:rPr>
-              <a:t>arquitectura</a:t>
-            </a:r>
-            <a:r>
-              <a:rPr sz="3200" b="1" dirty="0">
-                <a:solidFill>
-                  <a:srgbClr val="192D3E"/>
-                </a:solidFill>
-                <a:latin typeface="Arial"/>
-              </a:rPr>
-              <a:t> hexagonal</a:t>
+              <a:t>Disseny de ports de sortida en arquitectura hexagonal</a:t>
             </a:r>
           </a:p>
         </p:txBody>
@@ -3229,7 +3167,7 @@
         </p:nvSpPr>
         <p:spPr>
           <a:xfrm>
-            <a:off x="685800" y="2329500"/>
+            <a:off x="685800" y="2216685"/>
             <a:ext cx="9326880" cy="411480"/>
           </a:xfrm>
           <a:prstGeom prst="rect">
@@ -3245,7 +3183,7 @@
           <a:p>
             <a:pPr algn="l"/>
             <a:r>
-              <a:rPr lang="es-ES" sz="2100" b="0" dirty="0">
+              <a:rPr lang="es-ES" sz="2100" dirty="0">
                 <a:solidFill>
                   <a:srgbClr val="236092"/>
                 </a:solidFill>
@@ -3525,7 +3463,7 @@
                 </a:solidFill>
                 <a:latin typeface="Arial"/>
               </a:rPr>
-              <a:t>Conclusió</a:t>
+              <a:t>Flux i codi essencial</a:t>
             </a:r>
           </a:p>
         </p:txBody>
@@ -3560,7 +3498,7 @@
                 </a:solidFill>
                 <a:latin typeface="Arial"/>
               </a:rPr>
-              <a:t>L'arquitectura no elimina el canvi. El localitza.</a:t>
+              <a:t>El servei coordina. El domini decideix. La infraestructura adapta.</a:t>
             </a:r>
           </a:p>
         </p:txBody>
@@ -3635,7 +3573,7 @@
       </p:sp>
       <p:pic>
         <p:nvPicPr>
-          <p:cNvPr id="6" name="Picture 5" descr="before-after-comparison.png"/>
+          <p:cNvPr id="6" name="Picture 5" descr="sell-stock-sequence.png"/>
           <p:cNvPicPr>
             <a:picLocks noChangeAspect="1"/>
           </p:cNvPicPr>
@@ -3649,8 +3587,8 @@
         </p:blipFill>
         <p:spPr>
           <a:xfrm>
-            <a:off x="685800" y="1391858"/>
-            <a:ext cx="7086600" cy="4485763"/>
+            <a:off x="502920" y="1962677"/>
+            <a:ext cx="7315200" cy="3069806"/>
           </a:xfrm>
           <a:prstGeom prst="rect">
             <a:avLst/>
@@ -3659,14 +3597,98 @@
       </p:pic>
       <p:sp>
         <p:nvSpPr>
-          <p:cNvPr id="7" name="TextBox 6"/>
+          <p:cNvPr id="7" name="Rounded Rectangle 6"/>
+          <p:cNvSpPr/>
+          <p:nvPr/>
+        </p:nvSpPr>
+        <p:spPr>
+          <a:xfrm>
+            <a:off x="8092440" y="1645920"/>
+            <a:ext cx="3520440" cy="2423160"/>
+          </a:xfrm>
+          <a:prstGeom prst="roundRect">
+            <a:avLst/>
+          </a:prstGeom>
+          <a:solidFill>
+            <a:srgbClr val="1F2429"/>
+          </a:solidFill>
+          <a:ln>
+            <a:solidFill>
+              <a:srgbClr val="1F2429"/>
+            </a:solidFill>
+          </a:ln>
+        </p:spPr>
+        <p:style>
+          <a:lnRef idx="1">
+            <a:schemeClr val="accent1"/>
+          </a:lnRef>
+          <a:fillRef idx="3">
+            <a:schemeClr val="accent1"/>
+          </a:fillRef>
+          <a:effectRef idx="2">
+            <a:schemeClr val="accent1"/>
+          </a:effectRef>
+          <a:fontRef idx="minor">
+            <a:schemeClr val="lt1"/>
+          </a:fontRef>
+        </p:style>
+        <p:txBody>
+          <a:bodyPr rtlCol="0" anchor="ctr"/>
+          <a:lstStyle/>
+          <a:p>
+            <a:pPr algn="ctr"/>
+            <a:endParaRPr/>
+          </a:p>
+        </p:txBody>
+      </p:sp>
+      <p:sp>
+        <p:nvSpPr>
+          <p:cNvPr id="8" name="TextBox 7"/>
           <p:cNvSpPr txBox="1"/>
           <p:nvPr/>
         </p:nvSpPr>
         <p:spPr>
           <a:xfrm>
-            <a:off x="8183879" y="1874519"/>
-            <a:ext cx="2971800" cy="1737360"/>
+            <a:off x="8293608" y="1810512"/>
+            <a:ext cx="3118104" cy="2093976"/>
+          </a:xfrm>
+          <a:prstGeom prst="rect">
+            <a:avLst/>
+          </a:prstGeom>
+          <a:noFill/>
+        </p:spPr>
+        <p:txBody>
+          <a:bodyPr wrap="square">
+            <a:spAutoFit/>
+          </a:bodyPr>
+          <a:lstStyle/>
+          <a:p>
+            <a:r>
+              <a:rPr sz="1500">
+                <a:solidFill>
+                  <a:srgbClr val="F5F6F7"/>
+                </a:solidFill>
+                <a:latin typeface="Consolas"/>
+              </a:rPr>
+              <a:t>StockPrice stockPrice =
+    stockPriceProviderPort.fetchStockPrice(ticker);
+Price price = stockPrice.price();
+SellResult sellResult =
+    portfolio.sell(ticker, quantity, price);</a:t>
+            </a:r>
+          </a:p>
+        </p:txBody>
+      </p:sp>
+      <p:sp>
+        <p:nvSpPr>
+          <p:cNvPr id="9" name="TextBox 8"/>
+          <p:cNvSpPr txBox="1"/>
+          <p:nvPr/>
+        </p:nvSpPr>
+        <p:spPr>
+          <a:xfrm>
+            <a:off x="8138160" y="4434840"/>
+            <a:ext cx="3429000" cy="822960"/>
           </a:xfrm>
           <a:prstGeom prst="rect">
             <a:avLst/>
@@ -3679,29 +3701,29 @@
           </a:bodyPr>
           <a:lstStyle/>
           <a:p>
-            <a:pPr algn="ctr"/>
-            <a:r>
-              <a:rPr sz="2400" b="1">
+            <a:pPr algn="l"/>
+            <a:r>
+              <a:rPr sz="1700" b="0">
                 <a:solidFill>
                   <a:srgbClr val="192D3E"/>
                 </a:solidFill>
                 <a:latin typeface="Arial"/>
               </a:rPr>
-              <a:t>Quan el proveïdor canvia, volem canviar l'adaptador, no el cas d'ús ni el model de domini.</a:t>
-            </a:r>
-          </a:p>
-        </p:txBody>
-      </p:sp>
-      <p:sp>
-        <p:nvSpPr>
-          <p:cNvPr id="8" name="TextBox 7"/>
+              <a:t>El servei obté informació externa a través d'un port i delega la decisió al domini ric.</a:t>
+            </a:r>
+          </a:p>
+        </p:txBody>
+      </p:sp>
+      <p:sp>
+        <p:nvSpPr>
+          <p:cNvPr id="10" name="TextBox 9"/>
           <p:cNvSpPr txBox="1"/>
           <p:nvPr/>
         </p:nvSpPr>
         <p:spPr>
           <a:xfrm>
-            <a:off x="8183879" y="4160520"/>
-            <a:ext cx="2971800" cy="868680"/>
+            <a:off x="594360" y="6473952"/>
+            <a:ext cx="8595360" cy="201168"/>
           </a:xfrm>
           <a:prstGeom prst="rect">
             <a:avLst/>
@@ -3714,29 +3736,29 @@
           </a:bodyPr>
           <a:lstStyle/>
           <a:p>
-            <a:pPr algn="ctr"/>
-            <a:r>
-              <a:rPr sz="1700" b="0">
-                <a:solidFill>
-                  <a:srgbClr val="236092"/>
-                </a:solidFill>
-                <a:latin typeface="Arial"/>
-              </a:rPr>
-              <a:t>L'arquitectura fa explícita, substituïble i localitzada la dependència del món exterior.</a:t>
-            </a:r>
-          </a:p>
-        </p:txBody>
-      </p:sp>
-      <p:sp>
-        <p:nvSpPr>
-          <p:cNvPr id="9" name="TextBox 8"/>
+            <a:pPr algn="l"/>
+            <a:r>
+              <a:rPr sz="800" b="0">
+                <a:solidFill>
+                  <a:srgbClr val="66707A"/>
+                </a:solidFill>
+                <a:latin typeface="Arial"/>
+              </a:rPr>
+              <a:t>Disseny de Sistemes d'Informació · Ports de sortida en arquitectura hexagonal</a:t>
+            </a:r>
+          </a:p>
+        </p:txBody>
+      </p:sp>
+      <p:sp>
+        <p:nvSpPr>
+          <p:cNvPr id="11" name="TextBox 10"/>
           <p:cNvSpPr txBox="1"/>
           <p:nvPr/>
         </p:nvSpPr>
         <p:spPr>
           <a:xfrm>
-            <a:off x="594360" y="6473952"/>
-            <a:ext cx="8595360" cy="201168"/>
+            <a:off x="11155680" y="6473952"/>
+            <a:ext cx="411480" cy="201168"/>
           </a:xfrm>
           <a:prstGeom prst="rect">
             <a:avLst/>
@@ -3749,7 +3771,7 @@
           </a:bodyPr>
           <a:lstStyle/>
           <a:p>
-            <a:pPr algn="l"/>
+            <a:pPr algn="r"/>
             <a:r>
               <a:rPr sz="800" b="0">
                 <a:solidFill>
@@ -3757,21 +3779,46 @@
                 </a:solidFill>
                 <a:latin typeface="Arial"/>
               </a:rPr>
-              <a:t>Disseny de Sistemes d'Informació · Ports de sortida en arquitectura hexagonal</a:t>
-            </a:r>
-          </a:p>
-        </p:txBody>
-      </p:sp>
-      <p:sp>
-        <p:nvSpPr>
-          <p:cNvPr id="10" name="TextBox 9"/>
+              <a:t>10</a:t>
+            </a:r>
+          </a:p>
+        </p:txBody>
+      </p:sp>
+    </p:spTree>
+  </p:cSld>
+  <p:clrMapOvr>
+    <a:masterClrMapping/>
+  </p:clrMapOvr>
+</p:sld>
+</file>
+
+<file path=ppt/slides/slide11.xml><?xml version="1.0" encoding="utf-8"?>
+<p:sld xmlns:a="http://schemas.openxmlformats.org/drawingml/2006/main" xmlns:r="http://schemas.openxmlformats.org/officeDocument/2006/relationships" xmlns:p="http://schemas.openxmlformats.org/presentationml/2006/main">
+  <p:cSld>
+    <p:spTree>
+      <p:nvGrpSpPr>
+        <p:cNvPr id="1" name=""/>
+        <p:cNvGrpSpPr/>
+        <p:nvPr/>
+      </p:nvGrpSpPr>
+      <p:grpSpPr>
+        <a:xfrm>
+          <a:off x="0" y="0"/>
+          <a:ext cx="0" cy="0"/>
+          <a:chOff x="0" y="0"/>
+          <a:chExt cx="0" cy="0"/>
+        </a:xfrm>
+      </p:grpSpPr>
+      <p:sp>
+        <p:nvSpPr>
+          <p:cNvPr id="2" name="TextBox 1"/>
           <p:cNvSpPr txBox="1"/>
           <p:nvPr/>
         </p:nvSpPr>
         <p:spPr>
           <a:xfrm>
-            <a:off x="11155680" y="6473952"/>
-            <a:ext cx="411480" cy="201168"/>
+            <a:off x="594360" y="320040"/>
+            <a:ext cx="8961120" cy="502920"/>
           </a:xfrm>
           <a:prstGeom prst="rect">
             <a:avLst/>
@@ -3784,6 +3831,273 @@
           </a:bodyPr>
           <a:lstStyle/>
           <a:p>
+            <a:pPr algn="l"/>
+            <a:r>
+              <a:rPr sz="2800" b="1">
+                <a:solidFill>
+                  <a:srgbClr val="192D3E"/>
+                </a:solidFill>
+                <a:latin typeface="Arial"/>
+              </a:rPr>
+              <a:t>Conclusió</a:t>
+            </a:r>
+          </a:p>
+        </p:txBody>
+      </p:sp>
+      <p:sp>
+        <p:nvSpPr>
+          <p:cNvPr id="3" name="TextBox 2"/>
+          <p:cNvSpPr txBox="1"/>
+          <p:nvPr/>
+        </p:nvSpPr>
+        <p:spPr>
+          <a:xfrm>
+            <a:off x="612648" y="822960"/>
+            <a:ext cx="8869680" cy="320040"/>
+          </a:xfrm>
+          <a:prstGeom prst="rect">
+            <a:avLst/>
+          </a:prstGeom>
+          <a:noFill/>
+        </p:spPr>
+        <p:txBody>
+          <a:bodyPr wrap="square">
+            <a:normAutofit/>
+          </a:bodyPr>
+          <a:lstStyle/>
+          <a:p>
+            <a:pPr algn="l"/>
+            <a:r>
+              <a:rPr sz="1300" b="0">
+                <a:solidFill>
+                  <a:srgbClr val="66707A"/>
+                </a:solidFill>
+                <a:latin typeface="Arial"/>
+              </a:rPr>
+              <a:t>L'arquitectura no elimina el canvi. El localitza.</a:t>
+            </a:r>
+          </a:p>
+        </p:txBody>
+      </p:sp>
+      <p:pic>
+        <p:nvPicPr>
+          <p:cNvPr id="4" name="Picture 3" descr="logotip-oficial-tecnocampus-upf-horitzontal-color.png"/>
+          <p:cNvPicPr>
+            <a:picLocks noChangeAspect="1"/>
+          </p:cNvPicPr>
+          <p:nvPr/>
+        </p:nvPicPr>
+        <p:blipFill>
+          <a:blip r:embed="rId2"/>
+          <a:stretch>
+            <a:fillRect/>
+          </a:stretch>
+        </p:blipFill>
+        <p:spPr>
+          <a:xfrm>
+            <a:off x="9738360" y="293025"/>
+            <a:ext cx="1783079" cy="337493"/>
+          </a:xfrm>
+          <a:prstGeom prst="rect">
+            <a:avLst/>
+          </a:prstGeom>
+        </p:spPr>
+      </p:pic>
+      <p:sp>
+        <p:nvSpPr>
+          <p:cNvPr id="5" name="Rectangle 4"/>
+          <p:cNvSpPr/>
+          <p:nvPr/>
+        </p:nvSpPr>
+        <p:spPr>
+          <a:xfrm>
+            <a:off x="594360" y="1115568"/>
+            <a:ext cx="10972800" cy="13716"/>
+          </a:xfrm>
+          <a:prstGeom prst="rect">
+            <a:avLst/>
+          </a:prstGeom>
+          <a:solidFill>
+            <a:srgbClr val="D6DBE0"/>
+          </a:solidFill>
+          <a:ln>
+            <a:noFill/>
+          </a:ln>
+        </p:spPr>
+        <p:style>
+          <a:lnRef idx="1">
+            <a:schemeClr val="accent1"/>
+          </a:lnRef>
+          <a:fillRef idx="3">
+            <a:schemeClr val="accent1"/>
+          </a:fillRef>
+          <a:effectRef idx="2">
+            <a:schemeClr val="accent1"/>
+          </a:effectRef>
+          <a:fontRef idx="minor">
+            <a:schemeClr val="lt1"/>
+          </a:fontRef>
+        </p:style>
+        <p:txBody>
+          <a:bodyPr rtlCol="0" anchor="ctr"/>
+          <a:lstStyle/>
+          <a:p>
+            <a:pPr algn="ctr"/>
+            <a:endParaRPr/>
+          </a:p>
+        </p:txBody>
+      </p:sp>
+      <p:pic>
+        <p:nvPicPr>
+          <p:cNvPr id="6" name="Picture 5" descr="before-after-comparison.png"/>
+          <p:cNvPicPr>
+            <a:picLocks noChangeAspect="1"/>
+          </p:cNvPicPr>
+          <p:nvPr/>
+        </p:nvPicPr>
+        <p:blipFill>
+          <a:blip r:embed="rId3"/>
+          <a:stretch>
+            <a:fillRect/>
+          </a:stretch>
+        </p:blipFill>
+        <p:spPr>
+          <a:xfrm>
+            <a:off x="685800" y="1391858"/>
+            <a:ext cx="7086600" cy="4485763"/>
+          </a:xfrm>
+          <a:prstGeom prst="rect">
+            <a:avLst/>
+          </a:prstGeom>
+        </p:spPr>
+      </p:pic>
+      <p:sp>
+        <p:nvSpPr>
+          <p:cNvPr id="7" name="TextBox 6"/>
+          <p:cNvSpPr txBox="1"/>
+          <p:nvPr/>
+        </p:nvSpPr>
+        <p:spPr>
+          <a:xfrm>
+            <a:off x="8183879" y="1874519"/>
+            <a:ext cx="2971800" cy="1737360"/>
+          </a:xfrm>
+          <a:prstGeom prst="rect">
+            <a:avLst/>
+          </a:prstGeom>
+          <a:noFill/>
+        </p:spPr>
+        <p:txBody>
+          <a:bodyPr wrap="square">
+            <a:normAutofit/>
+          </a:bodyPr>
+          <a:lstStyle/>
+          <a:p>
+            <a:pPr algn="ctr"/>
+            <a:r>
+              <a:rPr sz="2400" b="1">
+                <a:solidFill>
+                  <a:srgbClr val="192D3E"/>
+                </a:solidFill>
+                <a:latin typeface="Arial"/>
+              </a:rPr>
+              <a:t>Quan el proveïdor canvia, volem canviar l'adaptador, no el cas d'ús ni el model de domini.</a:t>
+            </a:r>
+          </a:p>
+        </p:txBody>
+      </p:sp>
+      <p:sp>
+        <p:nvSpPr>
+          <p:cNvPr id="8" name="TextBox 7"/>
+          <p:cNvSpPr txBox="1"/>
+          <p:nvPr/>
+        </p:nvSpPr>
+        <p:spPr>
+          <a:xfrm>
+            <a:off x="8183879" y="4160520"/>
+            <a:ext cx="2971800" cy="868680"/>
+          </a:xfrm>
+          <a:prstGeom prst="rect">
+            <a:avLst/>
+          </a:prstGeom>
+          <a:noFill/>
+        </p:spPr>
+        <p:txBody>
+          <a:bodyPr wrap="square">
+            <a:normAutofit/>
+          </a:bodyPr>
+          <a:lstStyle/>
+          <a:p>
+            <a:pPr algn="ctr"/>
+            <a:r>
+              <a:rPr sz="1700" b="0">
+                <a:solidFill>
+                  <a:srgbClr val="236092"/>
+                </a:solidFill>
+                <a:latin typeface="Arial"/>
+              </a:rPr>
+              <a:t>L'arquitectura fa explícita, substituïble i localitzada la dependència del món exterior.</a:t>
+            </a:r>
+          </a:p>
+        </p:txBody>
+      </p:sp>
+      <p:sp>
+        <p:nvSpPr>
+          <p:cNvPr id="9" name="TextBox 8"/>
+          <p:cNvSpPr txBox="1"/>
+          <p:nvPr/>
+        </p:nvSpPr>
+        <p:spPr>
+          <a:xfrm>
+            <a:off x="594360" y="6473952"/>
+            <a:ext cx="8595360" cy="201168"/>
+          </a:xfrm>
+          <a:prstGeom prst="rect">
+            <a:avLst/>
+          </a:prstGeom>
+          <a:noFill/>
+        </p:spPr>
+        <p:txBody>
+          <a:bodyPr wrap="square">
+            <a:normAutofit/>
+          </a:bodyPr>
+          <a:lstStyle/>
+          <a:p>
+            <a:pPr algn="l"/>
+            <a:r>
+              <a:rPr sz="800" b="0">
+                <a:solidFill>
+                  <a:srgbClr val="66707A"/>
+                </a:solidFill>
+                <a:latin typeface="Arial"/>
+              </a:rPr>
+              <a:t>Disseny de Sistemes d'Informació · Ports de sortida en arquitectura hexagonal</a:t>
+            </a:r>
+          </a:p>
+        </p:txBody>
+      </p:sp>
+      <p:sp>
+        <p:nvSpPr>
+          <p:cNvPr id="10" name="TextBox 9"/>
+          <p:cNvSpPr txBox="1"/>
+          <p:nvPr/>
+        </p:nvSpPr>
+        <p:spPr>
+          <a:xfrm>
+            <a:off x="11155680" y="6473952"/>
+            <a:ext cx="411480" cy="201168"/>
+          </a:xfrm>
+          <a:prstGeom prst="rect">
+            <a:avLst/>
+          </a:prstGeom>
+          <a:noFill/>
+        </p:spPr>
+        <p:txBody>
+          <a:bodyPr wrap="square">
+            <a:normAutofit/>
+          </a:bodyPr>
+          <a:lstStyle/>
+          <a:p>
             <a:pPr algn="r"/>
             <a:r>
               <a:rPr sz="800" b="0">
@@ -3792,7 +4106,7 @@
                 </a:solidFill>
                 <a:latin typeface="Arial"/>
               </a:rPr>
-              <a:t>10</a:t>
+              <a:t>11</a:t>
             </a:r>
           </a:p>
         </p:txBody>
@@ -5152,7 +5466,7 @@
                 </a:solidFill>
                 <a:latin typeface="Arial"/>
               </a:rPr>
-              <a:t>El problema en sistemes reals</a:t>
+              <a:t>Cas funcional: avaluació econòmica d'una beca</a:t>
             </a:r>
           </a:p>
         </p:txBody>
@@ -5187,7 +5501,7 @@
                 </a:solidFill>
                 <a:latin typeface="Arial"/>
               </a:rPr>
-              <a:t>AGAUR, processos corporatius i informació externa</a:t>
+              <a:t>Abans de parlar d'arquitectura, cal entendre el procediment</a:t>
             </a:r>
           </a:p>
         </p:txBody>
@@ -5262,7 +5576,7 @@
       </p:sp>
       <p:pic>
         <p:nvPicPr>
-          <p:cNvPr id="6" name="Picture 5" descr="agaur-before-coupled.png"/>
+          <p:cNvPr id="6" name="Picture 5" descr="agaur-functional-scholarship.png"/>
           <p:cNvPicPr>
             <a:picLocks noChangeAspect="1"/>
           </p:cNvPicPr>
@@ -5276,8 +5590,8 @@
         </p:blipFill>
         <p:spPr>
           <a:xfrm>
-            <a:off x="502920" y="1450769"/>
-            <a:ext cx="11201400" cy="3224942"/>
+            <a:off x="2211537" y="1234440"/>
+            <a:ext cx="3760806" cy="4526280"/>
           </a:xfrm>
           <a:prstGeom prst="rect">
             <a:avLst/>
@@ -5292,8 +5606,8 @@
         </p:nvSpPr>
         <p:spPr>
           <a:xfrm>
-            <a:off x="777240" y="5074920"/>
-            <a:ext cx="6995160" cy="822960"/>
+            <a:off x="7909560" y="1508760"/>
+            <a:ext cx="3246120" cy="1417320"/>
           </a:xfrm>
           <a:prstGeom prst="rect">
             <a:avLst/>
@@ -5308,27 +5622,114 @@
           <a:p>
             <a:pPr algn="l"/>
             <a:r>
-              <a:rPr sz="1400" b="0">
+              <a:rPr sz="1800" b="1">
                 <a:solidFill>
                   <a:srgbClr val="192D3E"/>
                 </a:solidFill>
                 <a:latin typeface="Arial"/>
               </a:rPr>
-              <a:t>Lectura funcional: una sol·licitud de beca genera un expedient, s'avaluen requisits i es prepara una proposta de resolució. El risc arquitectònic apareix quan aquesta avaluació incorpora directament SOAP/XML, DTOs, mapping i detalls de PICA.</a:t>
-            </a:r>
-          </a:p>
-        </p:txBody>
-      </p:sp>
-      <p:sp>
-        <p:nvSpPr>
-          <p:cNvPr id="8" name="Rounded Rectangle 7"/>
+              <a:t>Una sol·licitud de beca genera un expedient. Després dels requisits generals, AGAUR revisa requisits econòmics de renda i patrimoni. Si no es compleixen, l'expedient no avança a la revisió acadèmica.</a:t>
+            </a:r>
+          </a:p>
+        </p:txBody>
+      </p:sp>
+      <p:sp>
+        <p:nvSpPr>
+          <p:cNvPr id="8" name="TextBox 7"/>
+          <p:cNvSpPr txBox="1"/>
+          <p:nvPr/>
+        </p:nvSpPr>
+        <p:spPr>
+          <a:xfrm>
+            <a:off x="7909560" y="3154680"/>
+            <a:ext cx="3246120" cy="1417320"/>
+          </a:xfrm>
+          <a:prstGeom prst="rect">
+            <a:avLst/>
+          </a:prstGeom>
+          <a:noFill/>
+        </p:spPr>
+        <p:txBody>
+          <a:bodyPr wrap="square">
+            <a:normAutofit/>
+          </a:bodyPr>
+          <a:lstStyle/>
+          <a:p>
+            <a:pPr>
+              <a:spcAft>
+                <a:spcPts val="800"/>
+              </a:spcAft>
+              <a:defRPr sz="1400">
+                <a:solidFill>
+                  <a:srgbClr val="262626"/>
+                </a:solidFill>
+                <a:latin typeface="Arial"/>
+              </a:defRPr>
+            </a:pPr>
+            <a:r>
+              <a:t>Renda familiar.</a:t>
+            </a:r>
+          </a:p>
+          <a:p>
+            <a:pPr>
+              <a:spcAft>
+                <a:spcPts val="800"/>
+              </a:spcAft>
+              <a:defRPr sz="1400">
+                <a:solidFill>
+                  <a:srgbClr val="262626"/>
+                </a:solidFill>
+                <a:latin typeface="Arial"/>
+              </a:defRPr>
+            </a:pPr>
+            <a:r>
+              <a:t>Patrimoni de la unitat familiar.</a:t>
+            </a:r>
+          </a:p>
+          <a:p>
+            <a:pPr>
+              <a:spcAft>
+                <a:spcPts val="800"/>
+              </a:spcAft>
+              <a:defRPr sz="1400">
+                <a:solidFill>
+                  <a:srgbClr val="262626"/>
+                </a:solidFill>
+                <a:latin typeface="Arial"/>
+              </a:defRPr>
+            </a:pPr>
+            <a:r>
+              <a:t>Finques urbanes i rústiques amb valors cadastrals.</a:t>
+            </a:r>
+          </a:p>
+          <a:p>
+            <a:pPr>
+              <a:spcAft>
+                <a:spcPts val="800"/>
+              </a:spcAft>
+              <a:defRPr sz="1400">
+                <a:solidFill>
+                  <a:srgbClr val="262626"/>
+                </a:solidFill>
+                <a:latin typeface="Arial"/>
+              </a:defRPr>
+            </a:pPr>
+            <a:r>
+              <a:t>Proposta de concessió o denegació.</a:t>
+            </a:r>
+          </a:p>
+        </p:txBody>
+      </p:sp>
+      <p:sp>
+        <p:nvSpPr>
+          <p:cNvPr id="9" name="Rounded Rectangle 8"/>
           <p:cNvSpPr/>
           <p:nvPr/>
         </p:nvSpPr>
         <p:spPr>
           <a:xfrm>
-            <a:off x="8138160" y="5074920"/>
-            <a:ext cx="3291840" cy="822960"/>
+            <a:off x="7909560" y="4983480"/>
+            <a:ext cx="3246120" cy="822960"/>
           </a:xfrm>
           <a:prstGeom prst="roundRect">
             <a:avLst/>
@@ -5367,14 +5768,14 @@
       </p:sp>
       <p:sp>
         <p:nvSpPr>
-          <p:cNvPr id="9" name="TextBox 8"/>
+          <p:cNvPr id="10" name="TextBox 9"/>
           <p:cNvSpPr txBox="1"/>
           <p:nvPr/>
         </p:nvSpPr>
         <p:spPr>
           <a:xfrm>
-            <a:off x="8321040" y="5193792"/>
-            <a:ext cx="2926080" cy="530352"/>
+            <a:off x="8092440" y="5138928"/>
+            <a:ext cx="2880360" cy="411480"/>
           </a:xfrm>
           <a:prstGeom prst="rect">
             <a:avLst/>
@@ -5389,21 +5790,20 @@
           <a:p>
             <a:pPr algn="ctr"/>
             <a:r>
-              <a:rPr sz="900" b="0">
+              <a:rPr sz="1000" b="0">
                 <a:solidFill>
                   <a:srgbClr val="66707A"/>
                 </a:solidFill>
                 <a:latin typeface="Arial"/>
               </a:rPr>
-              <a:t>Evidència documental
-Informe AGAUR: formació i consultoria especialitzada, 60 h, maig-juliol 2025, serveis REST i arquitectura hexagonal.</a:t>
-            </a:r>
-          </a:p>
-        </p:txBody>
-      </p:sp>
-      <p:sp>
-        <p:nvSpPr>
-          <p:cNvPr id="10" name="TextBox 9"/>
+              <a:t>Fonts públiques: AGAUR requisits econòmics i BOE 2025-2026 sobre llindars de renda i patrimoni.</a:t>
+            </a:r>
+          </a:p>
+        </p:txBody>
+      </p:sp>
+      <p:sp>
+        <p:nvSpPr>
+          <p:cNvPr id="11" name="TextBox 10"/>
           <p:cNvSpPr txBox="1"/>
           <p:nvPr/>
         </p:nvSpPr>
@@ -5438,7 +5838,7 @@
       </p:sp>
       <p:sp>
         <p:nvSpPr>
-          <p:cNvPr id="11" name="TextBox 10"/>
+          <p:cNvPr id="12" name="TextBox 11"/>
           <p:cNvSpPr txBox="1"/>
           <p:nvPr/>
         </p:nvSpPr>
@@ -5526,7 +5926,7 @@
                 </a:solidFill>
                 <a:latin typeface="Arial"/>
               </a:rPr>
-              <a:t>Quan l'acoblament es fa risc d'evolució</a:t>
+              <a:t>Quina informació externa necessita el procediment?</a:t>
             </a:r>
           </a:p>
         </p:txBody>
@@ -5555,76 +5955,13 @@
           <a:p>
             <a:pPr algn="l"/>
             <a:r>
-              <a:rPr sz="1300" b="0" dirty="0" err="1">
+              <a:rPr sz="1300" b="0">
                 <a:solidFill>
                   <a:srgbClr val="66707A"/>
                 </a:solidFill>
                 <a:latin typeface="Arial"/>
               </a:rPr>
-              <a:t>Lectura</a:t>
-            </a:r>
-            <a:r>
-              <a:rPr sz="1300" b="0" dirty="0">
-                <a:solidFill>
-                  <a:srgbClr val="66707A"/>
-                </a:solidFill>
-                <a:latin typeface="Arial"/>
-              </a:rPr>
-              <a:t> </a:t>
-            </a:r>
-            <a:r>
-              <a:rPr sz="1300" b="0" dirty="0" err="1">
-                <a:solidFill>
-                  <a:srgbClr val="66707A"/>
-                </a:solidFill>
-                <a:latin typeface="Arial"/>
-              </a:rPr>
-              <a:t>institucional</a:t>
-            </a:r>
-            <a:r>
-              <a:rPr sz="1300" b="0" dirty="0">
-                <a:solidFill>
-                  <a:srgbClr val="66707A"/>
-                </a:solidFill>
-                <a:latin typeface="Arial"/>
-              </a:rPr>
-              <a:t>: PICA, web services </a:t>
-            </a:r>
-            <a:r>
-              <a:rPr sz="1300" b="0" dirty="0" err="1">
-                <a:solidFill>
-                  <a:srgbClr val="66707A"/>
-                </a:solidFill>
-                <a:latin typeface="Arial"/>
-              </a:rPr>
-              <a:t>i</a:t>
-            </a:r>
-            <a:r>
-              <a:rPr sz="1300" b="0" dirty="0">
-                <a:solidFill>
-                  <a:srgbClr val="66707A"/>
-                </a:solidFill>
-                <a:latin typeface="Arial"/>
-              </a:rPr>
-              <a:t> </a:t>
-            </a:r>
-            <a:r>
-              <a:rPr sz="1300" b="0" dirty="0" err="1">
-                <a:solidFill>
-                  <a:srgbClr val="66707A"/>
-                </a:solidFill>
-                <a:latin typeface="Arial"/>
-              </a:rPr>
-              <a:t>orientació</a:t>
-            </a:r>
-            <a:r>
-              <a:rPr sz="1300" b="0" dirty="0">
-                <a:solidFill>
-                  <a:srgbClr val="66707A"/>
-                </a:solidFill>
-                <a:latin typeface="Arial"/>
-              </a:rPr>
-              <a:t> CTTI cap a APIs</a:t>
+              <a:t>Renda, patrimoni i informació cadastral</a:t>
             </a:r>
           </a:p>
         </p:txBody>
@@ -5697,16 +6034,40 @@
           </a:p>
         </p:txBody>
       </p:sp>
-      <p:sp>
-        <p:nvSpPr>
-          <p:cNvPr id="6" name="TextBox 5"/>
+      <p:pic>
+        <p:nvPicPr>
+          <p:cNvPr id="6" name="Picture 5" descr="agaur-data-interoperability.png"/>
+          <p:cNvPicPr>
+            <a:picLocks noChangeAspect="1"/>
+          </p:cNvPicPr>
+          <p:nvPr/>
+        </p:nvPicPr>
+        <p:blipFill>
+          <a:blip r:embed="rId3"/>
+          <a:stretch>
+            <a:fillRect/>
+          </a:stretch>
+        </p:blipFill>
+        <p:spPr>
+          <a:xfrm>
+            <a:off x="3053404" y="1234440"/>
+            <a:ext cx="2442831" cy="4526280"/>
+          </a:xfrm>
+          <a:prstGeom prst="rect">
+            <a:avLst/>
+          </a:prstGeom>
+        </p:spPr>
+      </p:pic>
+      <p:sp>
+        <p:nvSpPr>
+          <p:cNvPr id="7" name="TextBox 6"/>
           <p:cNvSpPr txBox="1"/>
           <p:nvPr/>
         </p:nvSpPr>
         <p:spPr>
           <a:xfrm>
-            <a:off x="822960" y="1298448"/>
-            <a:ext cx="10424160" cy="320040"/>
+            <a:off x="8229600" y="1508760"/>
+            <a:ext cx="2926080" cy="1234440"/>
           </a:xfrm>
           <a:prstGeom prst="rect">
             <a:avLst/>
@@ -5719,35 +6080,628 @@
           </a:bodyPr>
           <a:lstStyle/>
           <a:p>
-            <a:pPr algn="ctr"/>
-            <a:r>
-              <a:rPr sz="1600" b="1">
+            <a:pPr algn="l"/>
+            <a:r>
+              <a:rPr sz="1800" b="1" dirty="0">
                 <a:solidFill>
                   <a:srgbClr val="192D3E"/>
                 </a:solidFill>
                 <a:latin typeface="Arial"/>
               </a:rPr>
-              <a:t>La qüestió no és si SOAP desapareix: és que cap tecnologia d'integració ha d'arrossegar el procediment.</a:t>
-            </a:r>
-          </a:p>
-        </p:txBody>
-      </p:sp>
-      <p:sp>
-        <p:nvSpPr>
-          <p:cNvPr id="7" name="Rectangle 6"/>
+              <a:t>La </a:t>
+            </a:r>
+            <a:r>
+              <a:rPr sz="1800" b="1" dirty="0" err="1">
+                <a:solidFill>
+                  <a:srgbClr val="192D3E"/>
+                </a:solidFill>
+                <a:latin typeface="Arial"/>
+              </a:rPr>
+              <a:t>necessitat</a:t>
+            </a:r>
+            <a:r>
+              <a:rPr sz="1800" b="1" dirty="0">
+                <a:solidFill>
+                  <a:srgbClr val="192D3E"/>
+                </a:solidFill>
+                <a:latin typeface="Arial"/>
+              </a:rPr>
+              <a:t> </a:t>
+            </a:r>
+            <a:r>
+              <a:rPr sz="1800" b="1" dirty="0" err="1">
+                <a:solidFill>
+                  <a:srgbClr val="192D3E"/>
+                </a:solidFill>
+                <a:latin typeface="Arial"/>
+              </a:rPr>
+              <a:t>funcional</a:t>
+            </a:r>
+            <a:r>
+              <a:rPr sz="1800" b="1" dirty="0">
+                <a:solidFill>
+                  <a:srgbClr val="192D3E"/>
+                </a:solidFill>
+                <a:latin typeface="Arial"/>
+              </a:rPr>
+              <a:t> no </a:t>
+            </a:r>
+            <a:r>
+              <a:rPr sz="1800" b="1" dirty="0" err="1">
+                <a:solidFill>
+                  <a:srgbClr val="192D3E"/>
+                </a:solidFill>
+                <a:latin typeface="Arial"/>
+              </a:rPr>
+              <a:t>és</a:t>
+            </a:r>
+            <a:r>
+              <a:rPr sz="1800" b="1" dirty="0">
+                <a:solidFill>
+                  <a:srgbClr val="192D3E"/>
+                </a:solidFill>
+                <a:latin typeface="Arial"/>
+              </a:rPr>
+              <a:t> </a:t>
+            </a:r>
+            <a:r>
+              <a:rPr sz="1800" b="1" dirty="0" err="1">
+                <a:solidFill>
+                  <a:srgbClr val="192D3E"/>
+                </a:solidFill>
+                <a:latin typeface="Arial"/>
+              </a:rPr>
+              <a:t>consumir</a:t>
+            </a:r>
+            <a:r>
+              <a:rPr sz="1800" b="1" dirty="0">
+                <a:solidFill>
+                  <a:srgbClr val="192D3E"/>
+                </a:solidFill>
+                <a:latin typeface="Arial"/>
+              </a:rPr>
+              <a:t> </a:t>
+            </a:r>
+            <a:r>
+              <a:rPr sz="1800" b="1" dirty="0" err="1">
+                <a:solidFill>
+                  <a:srgbClr val="192D3E"/>
+                </a:solidFill>
+                <a:latin typeface="Arial"/>
+              </a:rPr>
+              <a:t>una</a:t>
+            </a:r>
+            <a:r>
+              <a:rPr sz="1800" b="1" dirty="0">
+                <a:solidFill>
+                  <a:srgbClr val="192D3E"/>
+                </a:solidFill>
+                <a:latin typeface="Arial"/>
+              </a:rPr>
+              <a:t> API </a:t>
+            </a:r>
+            <a:r>
+              <a:rPr sz="1800" b="1" dirty="0" err="1">
+                <a:solidFill>
+                  <a:srgbClr val="192D3E"/>
+                </a:solidFill>
+                <a:latin typeface="Arial"/>
+              </a:rPr>
+              <a:t>concreta</a:t>
+            </a:r>
+            <a:r>
+              <a:rPr sz="1800" b="1" dirty="0">
+                <a:solidFill>
+                  <a:srgbClr val="192D3E"/>
+                </a:solidFill>
+                <a:latin typeface="Arial"/>
+              </a:rPr>
+              <a:t>. </a:t>
+            </a:r>
+            <a:r>
+              <a:rPr sz="1800" b="1" dirty="0" err="1">
+                <a:solidFill>
+                  <a:srgbClr val="192D3E"/>
+                </a:solidFill>
+                <a:latin typeface="Arial"/>
+              </a:rPr>
+              <a:t>És</a:t>
+            </a:r>
+            <a:r>
+              <a:rPr sz="1800" b="1" dirty="0">
+                <a:solidFill>
+                  <a:srgbClr val="192D3E"/>
+                </a:solidFill>
+                <a:latin typeface="Arial"/>
+              </a:rPr>
+              <a:t> </a:t>
+            </a:r>
+            <a:r>
+              <a:rPr sz="1800" b="1" dirty="0" err="1">
+                <a:solidFill>
+                  <a:srgbClr val="192D3E"/>
+                </a:solidFill>
+                <a:latin typeface="Arial"/>
+              </a:rPr>
+              <a:t>obtenir</a:t>
+            </a:r>
+            <a:r>
+              <a:rPr sz="1800" b="1" dirty="0">
+                <a:solidFill>
+                  <a:srgbClr val="192D3E"/>
+                </a:solidFill>
+                <a:latin typeface="Arial"/>
+              </a:rPr>
+              <a:t> </a:t>
+            </a:r>
+            <a:r>
+              <a:rPr sz="1800" b="1" dirty="0" err="1">
+                <a:solidFill>
+                  <a:srgbClr val="192D3E"/>
+                </a:solidFill>
+                <a:latin typeface="Arial"/>
+              </a:rPr>
+              <a:t>informació</a:t>
+            </a:r>
+            <a:r>
+              <a:rPr sz="1800" b="1" dirty="0">
+                <a:solidFill>
+                  <a:srgbClr val="192D3E"/>
+                </a:solidFill>
+                <a:latin typeface="Arial"/>
+              </a:rPr>
+              <a:t> </a:t>
+            </a:r>
+            <a:r>
+              <a:rPr sz="1800" b="1" dirty="0" err="1">
+                <a:solidFill>
+                  <a:srgbClr val="192D3E"/>
+                </a:solidFill>
+                <a:latin typeface="Arial"/>
+              </a:rPr>
+              <a:t>administrativa</a:t>
+            </a:r>
+            <a:r>
+              <a:rPr sz="1800" b="1" dirty="0">
+                <a:solidFill>
+                  <a:srgbClr val="192D3E"/>
+                </a:solidFill>
+                <a:latin typeface="Arial"/>
+              </a:rPr>
+              <a:t> </a:t>
+            </a:r>
+            <a:r>
+              <a:rPr sz="1800" b="1" dirty="0" err="1">
+                <a:solidFill>
+                  <a:srgbClr val="192D3E"/>
+                </a:solidFill>
+                <a:latin typeface="Arial"/>
+              </a:rPr>
+              <a:t>fiable</a:t>
+            </a:r>
+            <a:r>
+              <a:rPr sz="1800" b="1" dirty="0">
+                <a:solidFill>
+                  <a:srgbClr val="192D3E"/>
+                </a:solidFill>
+                <a:latin typeface="Arial"/>
+              </a:rPr>
+              <a:t> per </a:t>
+            </a:r>
+            <a:r>
+              <a:rPr sz="1800" b="1" dirty="0" err="1">
+                <a:solidFill>
+                  <a:srgbClr val="192D3E"/>
+                </a:solidFill>
+                <a:latin typeface="Arial"/>
+              </a:rPr>
+              <a:t>avaluar</a:t>
+            </a:r>
+            <a:r>
+              <a:rPr sz="1800" b="1" dirty="0">
+                <a:solidFill>
+                  <a:srgbClr val="192D3E"/>
+                </a:solidFill>
+                <a:latin typeface="Arial"/>
+              </a:rPr>
+              <a:t> </a:t>
+            </a:r>
+            <a:r>
+              <a:rPr sz="1800" b="1" dirty="0" err="1">
+                <a:solidFill>
+                  <a:srgbClr val="192D3E"/>
+                </a:solidFill>
+                <a:latin typeface="Arial"/>
+              </a:rPr>
+              <a:t>si</a:t>
+            </a:r>
+            <a:r>
+              <a:rPr sz="1800" b="1" dirty="0">
+                <a:solidFill>
+                  <a:srgbClr val="192D3E"/>
+                </a:solidFill>
+                <a:latin typeface="Arial"/>
+              </a:rPr>
+              <a:t> </a:t>
+            </a:r>
+            <a:r>
+              <a:rPr sz="1800" b="1" dirty="0" err="1">
+                <a:solidFill>
+                  <a:srgbClr val="192D3E"/>
+                </a:solidFill>
+                <a:latin typeface="Arial"/>
+              </a:rPr>
+              <a:t>una</a:t>
+            </a:r>
+            <a:r>
+              <a:rPr sz="1800" b="1" dirty="0">
+                <a:solidFill>
+                  <a:srgbClr val="192D3E"/>
+                </a:solidFill>
+                <a:latin typeface="Arial"/>
+              </a:rPr>
+              <a:t> </a:t>
+            </a:r>
+            <a:r>
+              <a:rPr sz="1800" b="1" dirty="0" err="1">
+                <a:solidFill>
+                  <a:srgbClr val="192D3E"/>
+                </a:solidFill>
+                <a:latin typeface="Arial"/>
+              </a:rPr>
+              <a:t>sol·licitud</a:t>
+            </a:r>
+            <a:r>
+              <a:rPr sz="1800" b="1" dirty="0">
+                <a:solidFill>
+                  <a:srgbClr val="192D3E"/>
+                </a:solidFill>
+                <a:latin typeface="Arial"/>
+              </a:rPr>
+              <a:t> </a:t>
+            </a:r>
+            <a:r>
+              <a:rPr sz="1800" b="1" dirty="0" err="1">
+                <a:solidFill>
+                  <a:srgbClr val="192D3E"/>
+                </a:solidFill>
+                <a:latin typeface="Arial"/>
+              </a:rPr>
+              <a:t>compleix</a:t>
+            </a:r>
+            <a:r>
+              <a:rPr sz="1800" b="1" dirty="0">
+                <a:solidFill>
+                  <a:srgbClr val="192D3E"/>
+                </a:solidFill>
+                <a:latin typeface="Arial"/>
+              </a:rPr>
+              <a:t> </a:t>
+            </a:r>
+            <a:r>
+              <a:rPr sz="1800" b="1" dirty="0" err="1">
+                <a:solidFill>
+                  <a:srgbClr val="192D3E"/>
+                </a:solidFill>
+                <a:latin typeface="Arial"/>
+              </a:rPr>
+              <a:t>els</a:t>
+            </a:r>
+            <a:r>
+              <a:rPr sz="1800" b="1" dirty="0">
+                <a:solidFill>
+                  <a:srgbClr val="192D3E"/>
+                </a:solidFill>
+                <a:latin typeface="Arial"/>
+              </a:rPr>
+              <a:t> </a:t>
+            </a:r>
+            <a:r>
+              <a:rPr sz="1800" b="1" dirty="0" err="1">
+                <a:solidFill>
+                  <a:srgbClr val="192D3E"/>
+                </a:solidFill>
+                <a:latin typeface="Arial"/>
+              </a:rPr>
+              <a:t>requisits</a:t>
+            </a:r>
+            <a:r>
+              <a:rPr sz="1800" b="1" dirty="0">
+                <a:solidFill>
+                  <a:srgbClr val="192D3E"/>
+                </a:solidFill>
+                <a:latin typeface="Arial"/>
+              </a:rPr>
+              <a:t> </a:t>
+            </a:r>
+            <a:r>
+              <a:rPr sz="1800" b="1" dirty="0" err="1">
+                <a:solidFill>
+                  <a:srgbClr val="192D3E"/>
+                </a:solidFill>
+                <a:latin typeface="Arial"/>
+              </a:rPr>
+              <a:t>econòmics</a:t>
+            </a:r>
+            <a:r>
+              <a:rPr sz="1800" b="1" dirty="0">
+                <a:solidFill>
+                  <a:srgbClr val="192D3E"/>
+                </a:solidFill>
+                <a:latin typeface="Arial"/>
+              </a:rPr>
+              <a:t>.</a:t>
+            </a:r>
+          </a:p>
+        </p:txBody>
+      </p:sp>
+      <p:sp>
+        <p:nvSpPr>
+          <p:cNvPr id="8" name="TextBox 7"/>
+          <p:cNvSpPr txBox="1"/>
+          <p:nvPr/>
+        </p:nvSpPr>
+        <p:spPr>
+          <a:xfrm>
+            <a:off x="8229600" y="3063240"/>
+            <a:ext cx="2926080" cy="1691640"/>
+          </a:xfrm>
+          <a:prstGeom prst="rect">
+            <a:avLst/>
+          </a:prstGeom>
+          <a:noFill/>
+        </p:spPr>
+        <p:txBody>
+          <a:bodyPr wrap="square">
+            <a:normAutofit/>
+          </a:bodyPr>
+          <a:lstStyle/>
+          <a:p>
+            <a:pPr>
+              <a:spcAft>
+                <a:spcPts val="800"/>
+              </a:spcAft>
+              <a:defRPr sz="1200">
+                <a:solidFill>
+                  <a:srgbClr val="262626"/>
+                </a:solidFill>
+                <a:latin typeface="Arial"/>
+              </a:defRPr>
+            </a:pPr>
+            <a:r>
+              <a:rPr dirty="0"/>
+              <a:t>La </a:t>
+            </a:r>
+            <a:r>
+              <a:rPr dirty="0" err="1"/>
+              <a:t>sol·licitud</a:t>
+            </a:r>
+            <a:r>
+              <a:rPr dirty="0"/>
+              <a:t> </a:t>
+            </a:r>
+            <a:r>
+              <a:rPr dirty="0" err="1"/>
+              <a:t>autoritza</a:t>
+            </a:r>
+            <a:r>
+              <a:rPr dirty="0"/>
+              <a:t> la consulta de </a:t>
+            </a:r>
+            <a:r>
+              <a:rPr dirty="0" err="1"/>
+              <a:t>renda</a:t>
+            </a:r>
+            <a:r>
+              <a:rPr dirty="0"/>
+              <a:t> </a:t>
+            </a:r>
+            <a:r>
+              <a:rPr dirty="0" err="1"/>
+              <a:t>i</a:t>
+            </a:r>
+            <a:r>
+              <a:rPr dirty="0"/>
+              <a:t> </a:t>
+            </a:r>
+            <a:r>
+              <a:rPr dirty="0" err="1"/>
+              <a:t>patrimoni</a:t>
+            </a:r>
+            <a:r>
+              <a:rPr dirty="0"/>
+              <a:t>.</a:t>
+            </a:r>
+          </a:p>
+          <a:p>
+            <a:pPr>
+              <a:spcAft>
+                <a:spcPts val="800"/>
+              </a:spcAft>
+              <a:defRPr sz="1200">
+                <a:solidFill>
+                  <a:srgbClr val="262626"/>
+                </a:solidFill>
+                <a:latin typeface="Arial"/>
+              </a:defRPr>
+            </a:pPr>
+            <a:r>
+              <a:rPr dirty="0"/>
+              <a:t>El </a:t>
+            </a:r>
+            <a:r>
+              <a:rPr dirty="0" err="1"/>
+              <a:t>patrimoni</a:t>
+            </a:r>
+            <a:r>
+              <a:rPr dirty="0"/>
+              <a:t> pot </a:t>
+            </a:r>
+            <a:r>
+              <a:rPr dirty="0" err="1"/>
+              <a:t>incloure</a:t>
+            </a:r>
+            <a:r>
+              <a:rPr dirty="0"/>
+              <a:t> </a:t>
+            </a:r>
+            <a:r>
+              <a:rPr dirty="0" err="1"/>
+              <a:t>béns</a:t>
+            </a:r>
+            <a:r>
+              <a:rPr dirty="0"/>
+              <a:t> </a:t>
+            </a:r>
+            <a:r>
+              <a:rPr dirty="0" err="1"/>
+              <a:t>immobles</a:t>
+            </a:r>
+            <a:r>
+              <a:rPr dirty="0"/>
+              <a:t>.</a:t>
+            </a:r>
+          </a:p>
+          <a:p>
+            <a:pPr>
+              <a:spcAft>
+                <a:spcPts val="800"/>
+              </a:spcAft>
+              <a:defRPr sz="1200">
+                <a:solidFill>
+                  <a:srgbClr val="262626"/>
+                </a:solidFill>
+                <a:latin typeface="Arial"/>
+              </a:defRPr>
+            </a:pPr>
+            <a:r>
+              <a:rPr dirty="0"/>
+              <a:t>El valor cadastral pot </a:t>
+            </a:r>
+            <a:r>
+              <a:rPr dirty="0" err="1"/>
+              <a:t>influir</a:t>
+            </a:r>
+            <a:r>
+              <a:rPr dirty="0"/>
+              <a:t> </a:t>
+            </a:r>
+            <a:r>
+              <a:rPr dirty="0" err="1"/>
+              <a:t>en</a:t>
+            </a:r>
+            <a:r>
+              <a:rPr dirty="0"/>
+              <a:t> </a:t>
+            </a:r>
+            <a:r>
+              <a:rPr dirty="0" err="1"/>
+              <a:t>el</a:t>
+            </a:r>
+            <a:r>
+              <a:rPr dirty="0"/>
+              <a:t> </a:t>
+            </a:r>
+            <a:r>
+              <a:rPr dirty="0" err="1"/>
+              <a:t>resultat</a:t>
+            </a:r>
+            <a:r>
+              <a:rPr dirty="0"/>
+              <a:t> </a:t>
+            </a:r>
+            <a:r>
+              <a:rPr dirty="0" err="1"/>
+              <a:t>econòmic</a:t>
+            </a:r>
+            <a:r>
+              <a:rPr dirty="0"/>
+              <a:t>.</a:t>
+            </a:r>
+          </a:p>
+          <a:p>
+            <a:pPr>
+              <a:spcAft>
+                <a:spcPts val="800"/>
+              </a:spcAft>
+              <a:defRPr sz="1200">
+                <a:solidFill>
+                  <a:srgbClr val="262626"/>
+                </a:solidFill>
+                <a:latin typeface="Arial"/>
+              </a:defRPr>
+            </a:pPr>
+            <a:r>
+              <a:rPr dirty="0"/>
+              <a:t>La </a:t>
+            </a:r>
+            <a:r>
+              <a:rPr dirty="0" err="1"/>
+              <a:t>documentació</a:t>
+            </a:r>
+            <a:r>
+              <a:rPr dirty="0"/>
+              <a:t> </a:t>
+            </a:r>
+            <a:r>
+              <a:rPr dirty="0" err="1"/>
+              <a:t>pública</a:t>
+            </a:r>
+            <a:r>
+              <a:rPr dirty="0"/>
+              <a:t> vincula PICA </a:t>
+            </a:r>
+            <a:r>
+              <a:rPr dirty="0" err="1"/>
+              <a:t>amb</a:t>
+            </a:r>
+            <a:r>
+              <a:rPr dirty="0"/>
+              <a:t> </a:t>
+            </a:r>
+            <a:r>
+              <a:rPr dirty="0" err="1"/>
+              <a:t>dades</a:t>
+            </a:r>
+            <a:r>
+              <a:rPr dirty="0"/>
+              <a:t> de </a:t>
+            </a:r>
+            <a:r>
+              <a:rPr dirty="0" err="1"/>
+              <a:t>cadastre</a:t>
+            </a:r>
+            <a:r>
+              <a:rPr dirty="0"/>
+              <a:t> </a:t>
+            </a:r>
+            <a:r>
+              <a:rPr dirty="0" err="1"/>
+              <a:t>disponibles</a:t>
+            </a:r>
+            <a:r>
+              <a:rPr dirty="0"/>
+              <a:t> per AEAT.</a:t>
+            </a:r>
+          </a:p>
+        </p:txBody>
+      </p:sp>
+      <p:sp>
+        <p:nvSpPr>
+          <p:cNvPr id="9" name="Rounded Rectangle 8"/>
           <p:cNvSpPr/>
           <p:nvPr/>
         </p:nvSpPr>
         <p:spPr>
           <a:xfrm>
-            <a:off x="777240" y="1783080"/>
-            <a:ext cx="3246120" cy="2971800"/>
-          </a:xfrm>
-          <a:prstGeom prst="rect">
+            <a:off x="8229600" y="4892040"/>
+            <a:ext cx="2926080" cy="1005840"/>
+          </a:xfrm>
+          <a:prstGeom prst="roundRect">
             <a:avLst/>
           </a:prstGeom>
           <a:solidFill>
-            <a:srgbClr val="F8EAEA"/>
+            <a:srgbClr val="F7F8FA"/>
           </a:solidFill>
           <a:ln w="9525">
             <a:solidFill>
@@ -5780,14 +6734,14 @@
       </p:sp>
       <p:sp>
         <p:nvSpPr>
-          <p:cNvPr id="8" name="TextBox 7"/>
+          <p:cNvPr id="10" name="TextBox 9"/>
           <p:cNvSpPr txBox="1"/>
           <p:nvPr/>
         </p:nvSpPr>
         <p:spPr>
           <a:xfrm>
-            <a:off x="1005840" y="2011680"/>
-            <a:ext cx="2788920" cy="292608"/>
+            <a:off x="8394192" y="5029200"/>
+            <a:ext cx="2606040" cy="658368"/>
           </a:xfrm>
           <a:prstGeom prst="rect">
             <a:avLst/>
@@ -5802,51 +6756,27 @@
           <a:p>
             <a:pPr algn="ctr"/>
             <a:r>
-              <a:rPr sz="1800" b="1" dirty="0" err="1">
-                <a:solidFill>
-                  <a:srgbClr val="192D3E"/>
-                </a:solidFill>
-                <a:latin typeface="Arial"/>
-              </a:rPr>
-              <a:t>Situació</a:t>
-            </a:r>
-            <a:r>
-              <a:rPr sz="1800" b="1" dirty="0">
-                <a:solidFill>
-                  <a:srgbClr val="192D3E"/>
-                </a:solidFill>
-                <a:latin typeface="Arial"/>
-              </a:rPr>
-              <a:t> </a:t>
-            </a:r>
-            <a:r>
-              <a:rPr sz="1800" b="1" dirty="0" err="1">
-                <a:solidFill>
-                  <a:srgbClr val="192D3E"/>
-                </a:solidFill>
-                <a:latin typeface="Arial"/>
-              </a:rPr>
-              <a:t>verificable</a:t>
-            </a:r>
-            <a:endParaRPr sz="1800" b="1" dirty="0">
-              <a:solidFill>
-                <a:srgbClr val="192D3E"/>
-              </a:solidFill>
-              <a:latin typeface="Arial"/>
-            </a:endParaRPr>
-          </a:p>
-        </p:txBody>
-      </p:sp>
-      <p:sp>
-        <p:nvSpPr>
-          <p:cNvPr id="9" name="TextBox 8"/>
+              <a:rPr sz="800" b="0">
+                <a:solidFill>
+                  <a:srgbClr val="66707A"/>
+                </a:solidFill>
+                <a:latin typeface="Arial"/>
+              </a:rPr>
+              <a:t>Glossari mínim: PICA és interoperabilitat administrativa; Cadastre és registre de béns immobles; SOAP/XML és missatgeria i format d'integració.</a:t>
+            </a:r>
+          </a:p>
+        </p:txBody>
+      </p:sp>
+      <p:sp>
+        <p:nvSpPr>
+          <p:cNvPr id="11" name="TextBox 10"/>
           <p:cNvSpPr txBox="1"/>
           <p:nvPr/>
         </p:nvSpPr>
         <p:spPr>
           <a:xfrm>
-            <a:off x="1024128" y="2487168"/>
-            <a:ext cx="2788920" cy="640080"/>
+            <a:off x="594360" y="6473952"/>
+            <a:ext cx="8595360" cy="201168"/>
           </a:xfrm>
           <a:prstGeom prst="rect">
             <a:avLst/>
@@ -5859,919 +6789,14 @@
           </a:bodyPr>
           <a:lstStyle/>
           <a:p>
-            <a:pPr algn="ctr"/>
-            <a:r>
-              <a:rPr sz="1600" b="1" dirty="0">
-                <a:solidFill>
-                  <a:srgbClr val="192D3E"/>
-                </a:solidFill>
-                <a:latin typeface="Arial"/>
-              </a:rPr>
-              <a:t>PICA continua </a:t>
-            </a:r>
-            <a:r>
-              <a:rPr sz="1600" b="1" dirty="0" err="1">
-                <a:solidFill>
-                  <a:srgbClr val="192D3E"/>
-                </a:solidFill>
-                <a:latin typeface="Arial"/>
-              </a:rPr>
-              <a:t>essent</a:t>
-            </a:r>
-            <a:r>
-              <a:rPr sz="1600" b="1" dirty="0">
-                <a:solidFill>
-                  <a:srgbClr val="192D3E"/>
-                </a:solidFill>
-                <a:latin typeface="Arial"/>
-              </a:rPr>
-              <a:t> </a:t>
-            </a:r>
-            <a:r>
-              <a:rPr sz="1600" b="1" dirty="0" err="1">
-                <a:solidFill>
-                  <a:srgbClr val="192D3E"/>
-                </a:solidFill>
-                <a:latin typeface="Arial"/>
-              </a:rPr>
-              <a:t>una</a:t>
-            </a:r>
-            <a:r>
-              <a:rPr sz="1600" b="1" dirty="0">
-                <a:solidFill>
-                  <a:srgbClr val="192D3E"/>
-                </a:solidFill>
-                <a:latin typeface="Arial"/>
-              </a:rPr>
-              <a:t> </a:t>
-            </a:r>
-            <a:r>
-              <a:rPr sz="1600" b="1" dirty="0" err="1">
-                <a:solidFill>
-                  <a:srgbClr val="192D3E"/>
-                </a:solidFill>
-                <a:latin typeface="Arial"/>
-              </a:rPr>
-              <a:t>plataforma</a:t>
-            </a:r>
-            <a:r>
-              <a:rPr sz="1600" b="1" dirty="0">
-                <a:solidFill>
-                  <a:srgbClr val="192D3E"/>
-                </a:solidFill>
-                <a:latin typeface="Arial"/>
-              </a:rPr>
-              <a:t> </a:t>
-            </a:r>
-            <a:r>
-              <a:rPr sz="1600" b="1" dirty="0" err="1">
-                <a:solidFill>
-                  <a:srgbClr val="192D3E"/>
-                </a:solidFill>
-                <a:latin typeface="Arial"/>
-              </a:rPr>
-              <a:t>corporativa</a:t>
-            </a:r>
-            <a:r>
-              <a:rPr sz="1600" b="1" dirty="0">
-                <a:solidFill>
-                  <a:srgbClr val="192D3E"/>
-                </a:solidFill>
-                <a:latin typeface="Arial"/>
-              </a:rPr>
-              <a:t> </a:t>
-            </a:r>
-            <a:r>
-              <a:rPr sz="1600" b="1" dirty="0" err="1">
-                <a:solidFill>
-                  <a:srgbClr val="192D3E"/>
-                </a:solidFill>
-                <a:latin typeface="Arial"/>
-              </a:rPr>
-              <a:t>d'interoperabilitat</a:t>
-            </a:r>
-            <a:r>
-              <a:rPr sz="1600" b="1" dirty="0">
-                <a:solidFill>
-                  <a:srgbClr val="192D3E"/>
-                </a:solidFill>
-                <a:latin typeface="Arial"/>
-              </a:rPr>
-              <a:t>.</a:t>
-            </a:r>
-          </a:p>
-        </p:txBody>
-      </p:sp>
-      <p:sp>
-        <p:nvSpPr>
-          <p:cNvPr id="10" name="TextBox 9"/>
-          <p:cNvSpPr txBox="1"/>
-          <p:nvPr/>
-        </p:nvSpPr>
-        <p:spPr>
-          <a:xfrm>
-            <a:off x="1024128" y="3364992"/>
-            <a:ext cx="2788920" cy="640080"/>
-          </a:xfrm>
-          <a:prstGeom prst="rect">
-            <a:avLst/>
-          </a:prstGeom>
-          <a:noFill/>
-        </p:spPr>
-        <p:txBody>
-          <a:bodyPr wrap="square">
-            <a:normAutofit/>
-          </a:bodyPr>
-          <a:lstStyle/>
-          <a:p>
-            <a:pPr algn="ctr"/>
-            <a:r>
-              <a:rPr sz="1400" b="0">
-                <a:solidFill>
-                  <a:srgbClr val="262626"/>
-                </a:solidFill>
-                <a:latin typeface="Arial"/>
-              </a:rPr>
-              <a:t>La documentació pública mostra integració amb web services i antecedents SOAP.</a:t>
-            </a:r>
-          </a:p>
-        </p:txBody>
-      </p:sp>
-      <p:sp>
-        <p:nvSpPr>
-          <p:cNvPr id="11" name="TextBox 10"/>
-          <p:cNvSpPr txBox="1"/>
-          <p:nvPr/>
-        </p:nvSpPr>
-        <p:spPr>
-          <a:xfrm>
-            <a:off x="1024128" y="4114800"/>
-            <a:ext cx="2788920" cy="320040"/>
-          </a:xfrm>
-          <a:prstGeom prst="rect">
-            <a:avLst/>
-          </a:prstGeom>
-          <a:noFill/>
-        </p:spPr>
-        <p:txBody>
-          <a:bodyPr wrap="square">
-            <a:normAutofit/>
-          </a:bodyPr>
-          <a:lstStyle/>
-          <a:p>
-            <a:pPr algn="ctr"/>
-            <a:r>
-              <a:rPr sz="1700" b="1">
-                <a:solidFill>
-                  <a:srgbClr val="236092"/>
-                </a:solidFill>
-                <a:latin typeface="Arial"/>
-              </a:rPr>
-              <a:t>PICA / web services</a:t>
-            </a:r>
-          </a:p>
-        </p:txBody>
-      </p:sp>
-      <p:sp>
-        <p:nvSpPr>
-          <p:cNvPr id="12" name="Rectangle 11"/>
-          <p:cNvSpPr/>
-          <p:nvPr/>
-        </p:nvSpPr>
-        <p:spPr>
-          <a:xfrm>
-            <a:off x="4434840" y="1783080"/>
-            <a:ext cx="3246120" cy="2971800"/>
-          </a:xfrm>
-          <a:prstGeom prst="rect">
-            <a:avLst/>
-          </a:prstGeom>
-          <a:solidFill>
-            <a:srgbClr val="FFF3D6"/>
-          </a:solidFill>
-          <a:ln w="9525">
-            <a:solidFill>
-              <a:srgbClr val="DCE0E4"/>
-            </a:solidFill>
-          </a:ln>
-        </p:spPr>
-        <p:style>
-          <a:lnRef idx="1">
-            <a:schemeClr val="accent1"/>
-          </a:lnRef>
-          <a:fillRef idx="3">
-            <a:schemeClr val="accent1"/>
-          </a:fillRef>
-          <a:effectRef idx="2">
-            <a:schemeClr val="accent1"/>
-          </a:effectRef>
-          <a:fontRef idx="minor">
-            <a:schemeClr val="lt1"/>
-          </a:fontRef>
-        </p:style>
-        <p:txBody>
-          <a:bodyPr rtlCol="0" anchor="ctr"/>
-          <a:lstStyle/>
-          <a:p>
-            <a:pPr algn="ctr"/>
-            <a:endParaRPr/>
-          </a:p>
-        </p:txBody>
-      </p:sp>
-      <p:sp>
-        <p:nvSpPr>
-          <p:cNvPr id="13" name="TextBox 12"/>
-          <p:cNvSpPr txBox="1"/>
-          <p:nvPr/>
-        </p:nvSpPr>
-        <p:spPr>
-          <a:xfrm>
-            <a:off x="4663440" y="2011680"/>
-            <a:ext cx="2788920" cy="292608"/>
-          </a:xfrm>
-          <a:prstGeom prst="rect">
-            <a:avLst/>
-          </a:prstGeom>
-          <a:noFill/>
-        </p:spPr>
-        <p:txBody>
-          <a:bodyPr wrap="square">
-            <a:normAutofit/>
-          </a:bodyPr>
-          <a:lstStyle/>
-          <a:p>
-            <a:pPr algn="ctr"/>
-            <a:r>
-              <a:rPr sz="1800" b="1">
-                <a:solidFill>
-                  <a:srgbClr val="192D3E"/>
-                </a:solidFill>
-                <a:latin typeface="Arial"/>
-              </a:rPr>
-              <a:t>Risc arquitectònic</a:t>
-            </a:r>
-          </a:p>
-        </p:txBody>
-      </p:sp>
-      <p:sp>
-        <p:nvSpPr>
-          <p:cNvPr id="14" name="TextBox 13"/>
-          <p:cNvSpPr txBox="1"/>
-          <p:nvPr/>
-        </p:nvSpPr>
-        <p:spPr>
-          <a:xfrm>
-            <a:off x="4681728" y="2514600"/>
-            <a:ext cx="2788920" cy="1737360"/>
-          </a:xfrm>
-          <a:prstGeom prst="rect">
-            <a:avLst/>
-          </a:prstGeom>
-          <a:noFill/>
-        </p:spPr>
-        <p:txBody>
-          <a:bodyPr wrap="square">
-            <a:normAutofit/>
-          </a:bodyPr>
-          <a:lstStyle/>
-          <a:p>
-            <a:pPr>
-              <a:spcAft>
-                <a:spcPts val="800"/>
-              </a:spcAft>
-              <a:defRPr sz="1200">
-                <a:solidFill>
-                  <a:srgbClr val="262626"/>
-                </a:solidFill>
-                <a:latin typeface="Arial"/>
-              </a:defRPr>
-            </a:pPr>
-            <a:r>
-              <a:rPr dirty="0"/>
-              <a:t>El flux de </a:t>
-            </a:r>
-            <a:r>
-              <a:rPr dirty="0" err="1"/>
-              <a:t>l'expedient</a:t>
-            </a:r>
-            <a:r>
-              <a:rPr dirty="0"/>
-              <a:t> </a:t>
-            </a:r>
-            <a:r>
-              <a:rPr dirty="0" err="1"/>
-              <a:t>coneix</a:t>
-            </a:r>
-            <a:r>
-              <a:rPr dirty="0"/>
-              <a:t> PICA, SOAP/XML, DTOs, mapping </a:t>
-            </a:r>
-            <a:r>
-              <a:rPr dirty="0" err="1"/>
-              <a:t>i</a:t>
-            </a:r>
-            <a:r>
-              <a:rPr dirty="0"/>
-              <a:t> errors </a:t>
-            </a:r>
-            <a:r>
-              <a:rPr dirty="0" err="1"/>
-              <a:t>tècnics</a:t>
-            </a:r>
-            <a:r>
-              <a:rPr dirty="0"/>
-              <a:t>.</a:t>
-            </a:r>
-          </a:p>
-          <a:p>
-            <a:pPr>
-              <a:spcAft>
-                <a:spcPts val="800"/>
-              </a:spcAft>
-              <a:defRPr sz="1200">
-                <a:solidFill>
-                  <a:srgbClr val="262626"/>
-                </a:solidFill>
-                <a:latin typeface="Arial"/>
-              </a:defRPr>
-            </a:pPr>
-            <a:r>
-              <a:rPr dirty="0"/>
-              <a:t>La </a:t>
-            </a:r>
-            <a:r>
-              <a:rPr dirty="0" err="1"/>
-              <a:t>lògica</a:t>
-            </a:r>
-            <a:r>
-              <a:rPr dirty="0"/>
-              <a:t> </a:t>
-            </a:r>
-            <a:r>
-              <a:rPr dirty="0" err="1"/>
-              <a:t>administrativa</a:t>
-            </a:r>
-            <a:r>
-              <a:rPr dirty="0"/>
-              <a:t> </a:t>
-            </a:r>
-            <a:r>
-              <a:rPr dirty="0" err="1"/>
-              <a:t>depèn</a:t>
-            </a:r>
-            <a:r>
-              <a:rPr dirty="0"/>
-              <a:t> </a:t>
-            </a:r>
-            <a:r>
-              <a:rPr dirty="0" err="1"/>
-              <a:t>d'una</a:t>
-            </a:r>
-            <a:r>
-              <a:rPr dirty="0"/>
-              <a:t> </a:t>
-            </a:r>
-            <a:r>
-              <a:rPr dirty="0" err="1"/>
-              <a:t>tecnologia</a:t>
-            </a:r>
-            <a:r>
-              <a:rPr dirty="0"/>
-              <a:t> </a:t>
-            </a:r>
-            <a:r>
-              <a:rPr dirty="0" err="1"/>
-              <a:t>d'integració</a:t>
-            </a:r>
-            <a:r>
-              <a:rPr dirty="0"/>
-              <a:t> </a:t>
-            </a:r>
-            <a:r>
-              <a:rPr dirty="0" err="1"/>
-              <a:t>concreta</a:t>
-            </a:r>
-            <a:r>
-              <a:rPr dirty="0"/>
-              <a:t>.</a:t>
-            </a:r>
-          </a:p>
-          <a:p>
-            <a:pPr>
-              <a:spcAft>
-                <a:spcPts val="800"/>
-              </a:spcAft>
-              <a:defRPr sz="1200">
-                <a:solidFill>
-                  <a:srgbClr val="262626"/>
-                </a:solidFill>
-                <a:latin typeface="Arial"/>
-              </a:defRPr>
-            </a:pPr>
-            <a:r>
-              <a:rPr dirty="0" err="1"/>
-              <a:t>Qualsevol</a:t>
-            </a:r>
-            <a:r>
-              <a:rPr dirty="0"/>
-              <a:t> </a:t>
-            </a:r>
-            <a:r>
-              <a:rPr dirty="0" err="1"/>
-              <a:t>evolució</a:t>
-            </a:r>
-            <a:r>
-              <a:rPr dirty="0"/>
-              <a:t> cap a REST, API Manager o EventHub </a:t>
-            </a:r>
-            <a:r>
-              <a:rPr dirty="0" err="1"/>
-              <a:t>impacta</a:t>
-            </a:r>
-            <a:r>
-              <a:rPr dirty="0"/>
-              <a:t> </a:t>
-            </a:r>
-            <a:r>
-              <a:rPr dirty="0" err="1"/>
-              <a:t>massa</a:t>
-            </a:r>
-            <a:r>
-              <a:rPr dirty="0"/>
-              <a:t> capes.</a:t>
-            </a:r>
-          </a:p>
-        </p:txBody>
-      </p:sp>
-      <p:sp>
-        <p:nvSpPr>
-          <p:cNvPr id="15" name="Rectangle 14"/>
-          <p:cNvSpPr/>
-          <p:nvPr/>
-        </p:nvSpPr>
-        <p:spPr>
-          <a:xfrm>
-            <a:off x="8092440" y="1783080"/>
-            <a:ext cx="3246120" cy="2971800"/>
-          </a:xfrm>
-          <a:prstGeom prst="rect">
-            <a:avLst/>
-          </a:prstGeom>
-          <a:solidFill>
-            <a:srgbClr val="E8F1F8"/>
-          </a:solidFill>
-          <a:ln w="9525">
-            <a:solidFill>
-              <a:srgbClr val="DCE0E4"/>
-            </a:solidFill>
-          </a:ln>
-        </p:spPr>
-        <p:style>
-          <a:lnRef idx="1">
-            <a:schemeClr val="accent1"/>
-          </a:lnRef>
-          <a:fillRef idx="3">
-            <a:schemeClr val="accent1"/>
-          </a:fillRef>
-          <a:effectRef idx="2">
-            <a:schemeClr val="accent1"/>
-          </a:effectRef>
-          <a:fontRef idx="minor">
-            <a:schemeClr val="lt1"/>
-          </a:fontRef>
-        </p:style>
-        <p:txBody>
-          <a:bodyPr rtlCol="0" anchor="ctr"/>
-          <a:lstStyle/>
-          <a:p>
-            <a:pPr algn="ctr"/>
-            <a:endParaRPr/>
-          </a:p>
-        </p:txBody>
-      </p:sp>
-      <p:sp>
-        <p:nvSpPr>
-          <p:cNvPr id="16" name="TextBox 15"/>
-          <p:cNvSpPr txBox="1"/>
-          <p:nvPr/>
-        </p:nvSpPr>
-        <p:spPr>
-          <a:xfrm>
-            <a:off x="8321040" y="2011680"/>
-            <a:ext cx="2788920" cy="292608"/>
-          </a:xfrm>
-          <a:prstGeom prst="rect">
-            <a:avLst/>
-          </a:prstGeom>
-          <a:noFill/>
-        </p:spPr>
-        <p:txBody>
-          <a:bodyPr wrap="square">
-            <a:normAutofit/>
-          </a:bodyPr>
-          <a:lstStyle/>
-          <a:p>
-            <a:pPr algn="ctr"/>
-            <a:r>
-              <a:rPr sz="1800" b="1">
-                <a:solidFill>
-                  <a:srgbClr val="192D3E"/>
-                </a:solidFill>
-                <a:latin typeface="Arial"/>
-              </a:rPr>
-              <a:t>Criteri docent</a:t>
-            </a:r>
-          </a:p>
-        </p:txBody>
-      </p:sp>
-      <p:sp>
-        <p:nvSpPr>
-          <p:cNvPr id="17" name="TextBox 16"/>
-          <p:cNvSpPr txBox="1"/>
-          <p:nvPr/>
-        </p:nvSpPr>
-        <p:spPr>
-          <a:xfrm>
-            <a:off x="8339327" y="2542032"/>
-            <a:ext cx="2788920" cy="685800"/>
-          </a:xfrm>
-          <a:prstGeom prst="rect">
-            <a:avLst/>
-          </a:prstGeom>
-          <a:noFill/>
-        </p:spPr>
-        <p:txBody>
-          <a:bodyPr wrap="square">
-            <a:normAutofit/>
-          </a:bodyPr>
-          <a:lstStyle/>
-          <a:p>
-            <a:pPr algn="ctr"/>
-            <a:r>
-              <a:rPr sz="1600" b="1">
-                <a:solidFill>
-                  <a:srgbClr val="192D3E"/>
-                </a:solidFill>
-                <a:latin typeface="Arial"/>
-              </a:rPr>
-              <a:t>Separar criteris del procediment, casos d'ús i infraestructura.</a:t>
-            </a:r>
-          </a:p>
-        </p:txBody>
-      </p:sp>
-      <p:sp>
-        <p:nvSpPr>
-          <p:cNvPr id="18" name="TextBox 17"/>
-          <p:cNvSpPr txBox="1"/>
-          <p:nvPr/>
-        </p:nvSpPr>
-        <p:spPr>
-          <a:xfrm>
-            <a:off x="8339327" y="3474720"/>
-            <a:ext cx="2788920" cy="777240"/>
-          </a:xfrm>
-          <a:prstGeom prst="rect">
-            <a:avLst/>
-          </a:prstGeom>
-          <a:noFill/>
-        </p:spPr>
-        <p:txBody>
-          <a:bodyPr wrap="square">
-            <a:normAutofit/>
-          </a:bodyPr>
-          <a:lstStyle/>
-          <a:p>
-            <a:pPr algn="ctr"/>
-            <a:r>
-              <a:rPr sz="1800" b="1">
-                <a:solidFill>
-                  <a:srgbClr val="236092"/>
-                </a:solidFill>
-                <a:latin typeface="Arial"/>
-              </a:rPr>
-              <a:t>Port de sortida
-+
-adaptadors substituïbles</a:t>
-            </a:r>
-          </a:p>
-        </p:txBody>
-      </p:sp>
-      <p:sp>
-        <p:nvSpPr>
-          <p:cNvPr id="19" name="TextBox 18"/>
-          <p:cNvSpPr txBox="1"/>
-          <p:nvPr/>
-        </p:nvSpPr>
-        <p:spPr>
-          <a:xfrm>
-            <a:off x="1051560" y="5074920"/>
-            <a:ext cx="6949440" cy="566928"/>
-          </a:xfrm>
-          <a:prstGeom prst="rect">
-            <a:avLst/>
-          </a:prstGeom>
-          <a:noFill/>
-        </p:spPr>
-        <p:txBody>
-          <a:bodyPr wrap="square">
-            <a:normAutofit/>
-          </a:bodyPr>
-          <a:lstStyle/>
-          <a:p>
             <a:pPr algn="l"/>
             <a:r>
-              <a:rPr sz="1700" b="1" dirty="0">
-                <a:solidFill>
-                  <a:srgbClr val="192D3E"/>
-                </a:solidFill>
-                <a:latin typeface="Arial"/>
-              </a:rPr>
-              <a:t>El </a:t>
-            </a:r>
-            <a:r>
-              <a:rPr sz="1700" b="1" dirty="0" err="1">
-                <a:solidFill>
-                  <a:srgbClr val="192D3E"/>
-                </a:solidFill>
-                <a:latin typeface="Arial"/>
-              </a:rPr>
-              <a:t>motiu</a:t>
-            </a:r>
-            <a:r>
-              <a:rPr sz="1700" b="1" dirty="0">
-                <a:solidFill>
-                  <a:srgbClr val="192D3E"/>
-                </a:solidFill>
-                <a:latin typeface="Arial"/>
-              </a:rPr>
-              <a:t> </a:t>
-            </a:r>
-            <a:r>
-              <a:rPr sz="1700" b="1" dirty="0" err="1">
-                <a:solidFill>
-                  <a:srgbClr val="192D3E"/>
-                </a:solidFill>
-                <a:latin typeface="Arial"/>
-              </a:rPr>
-              <a:t>arquitectònic</a:t>
-            </a:r>
-            <a:r>
-              <a:rPr sz="1700" b="1" dirty="0">
-                <a:solidFill>
-                  <a:srgbClr val="192D3E"/>
-                </a:solidFill>
-                <a:latin typeface="Arial"/>
-              </a:rPr>
-              <a:t> no </a:t>
-            </a:r>
-            <a:r>
-              <a:rPr sz="1700" b="1" dirty="0" err="1">
-                <a:solidFill>
-                  <a:srgbClr val="192D3E"/>
-                </a:solidFill>
-                <a:latin typeface="Arial"/>
-              </a:rPr>
-              <a:t>és</a:t>
-            </a:r>
-            <a:r>
-              <a:rPr sz="1700" b="1" dirty="0">
-                <a:solidFill>
-                  <a:srgbClr val="192D3E"/>
-                </a:solidFill>
-                <a:latin typeface="Arial"/>
-              </a:rPr>
-              <a:t> </a:t>
-            </a:r>
-            <a:r>
-              <a:rPr sz="1700" b="1" dirty="0" err="1">
-                <a:solidFill>
-                  <a:srgbClr val="192D3E"/>
-                </a:solidFill>
-                <a:latin typeface="Arial"/>
-              </a:rPr>
-              <a:t>només</a:t>
-            </a:r>
-            <a:r>
-              <a:rPr sz="1700" b="1" dirty="0">
-                <a:solidFill>
-                  <a:srgbClr val="192D3E"/>
-                </a:solidFill>
-                <a:latin typeface="Arial"/>
-              </a:rPr>
-              <a:t> "fer REST": </a:t>
-            </a:r>
-            <a:r>
-              <a:rPr sz="1700" b="1" dirty="0" err="1">
-                <a:solidFill>
-                  <a:srgbClr val="192D3E"/>
-                </a:solidFill>
-                <a:latin typeface="Arial"/>
-              </a:rPr>
-              <a:t>és</a:t>
-            </a:r>
-            <a:r>
-              <a:rPr sz="1700" b="1" dirty="0">
-                <a:solidFill>
-                  <a:srgbClr val="192D3E"/>
-                </a:solidFill>
-                <a:latin typeface="Arial"/>
-              </a:rPr>
-              <a:t> </a:t>
-            </a:r>
-            <a:r>
-              <a:rPr sz="1700" b="1" dirty="0" err="1">
-                <a:solidFill>
-                  <a:srgbClr val="192D3E"/>
-                </a:solidFill>
-                <a:latin typeface="Arial"/>
-              </a:rPr>
-              <a:t>evitar</a:t>
-            </a:r>
-            <a:r>
-              <a:rPr sz="1700" b="1" dirty="0">
-                <a:solidFill>
-                  <a:srgbClr val="192D3E"/>
-                </a:solidFill>
-                <a:latin typeface="Arial"/>
-              </a:rPr>
-              <a:t> que </a:t>
-            </a:r>
-            <a:r>
-              <a:rPr sz="1700" b="1" dirty="0" err="1">
-                <a:solidFill>
-                  <a:srgbClr val="192D3E"/>
-                </a:solidFill>
-                <a:latin typeface="Arial"/>
-              </a:rPr>
-              <a:t>l'evolució</a:t>
-            </a:r>
-            <a:r>
-              <a:rPr sz="1700" b="1" dirty="0">
-                <a:solidFill>
-                  <a:srgbClr val="192D3E"/>
-                </a:solidFill>
-                <a:latin typeface="Arial"/>
-              </a:rPr>
-              <a:t> </a:t>
-            </a:r>
-            <a:r>
-              <a:rPr sz="1700" b="1" dirty="0" err="1">
-                <a:solidFill>
-                  <a:srgbClr val="192D3E"/>
-                </a:solidFill>
-                <a:latin typeface="Arial"/>
-              </a:rPr>
-              <a:t>tecnològica</a:t>
-            </a:r>
-            <a:r>
-              <a:rPr sz="1700" b="1" dirty="0">
-                <a:solidFill>
-                  <a:srgbClr val="192D3E"/>
-                </a:solidFill>
-                <a:latin typeface="Arial"/>
-              </a:rPr>
-              <a:t> </a:t>
-            </a:r>
-            <a:r>
-              <a:rPr sz="1700" b="1" dirty="0" err="1">
-                <a:solidFill>
-                  <a:srgbClr val="192D3E"/>
-                </a:solidFill>
-                <a:latin typeface="Arial"/>
-              </a:rPr>
-              <a:t>arrossegui</a:t>
-            </a:r>
-            <a:r>
-              <a:rPr sz="1700" b="1" dirty="0">
-                <a:solidFill>
-                  <a:srgbClr val="192D3E"/>
-                </a:solidFill>
-                <a:latin typeface="Arial"/>
-              </a:rPr>
-              <a:t> </a:t>
-            </a:r>
-            <a:r>
-              <a:rPr sz="1700" b="1" dirty="0" err="1">
-                <a:solidFill>
-                  <a:srgbClr val="192D3E"/>
-                </a:solidFill>
-                <a:latin typeface="Arial"/>
-              </a:rPr>
-              <a:t>els</a:t>
-            </a:r>
-            <a:r>
-              <a:rPr sz="1700" b="1" dirty="0">
-                <a:solidFill>
-                  <a:srgbClr val="192D3E"/>
-                </a:solidFill>
-                <a:latin typeface="Arial"/>
-              </a:rPr>
-              <a:t> </a:t>
-            </a:r>
-            <a:r>
-              <a:rPr sz="1700" b="1" dirty="0" err="1">
-                <a:solidFill>
-                  <a:srgbClr val="192D3E"/>
-                </a:solidFill>
-                <a:latin typeface="Arial"/>
-              </a:rPr>
-              <a:t>casos</a:t>
-            </a:r>
-            <a:r>
-              <a:rPr sz="1700" b="1" dirty="0">
-                <a:solidFill>
-                  <a:srgbClr val="192D3E"/>
-                </a:solidFill>
-                <a:latin typeface="Arial"/>
-              </a:rPr>
-              <a:t> </a:t>
-            </a:r>
-            <a:r>
-              <a:rPr sz="1700" b="1" dirty="0" err="1">
-                <a:solidFill>
-                  <a:srgbClr val="192D3E"/>
-                </a:solidFill>
-                <a:latin typeface="Arial"/>
-              </a:rPr>
-              <a:t>d'ús</a:t>
-            </a:r>
-            <a:r>
-              <a:rPr sz="1700" b="1" dirty="0">
-                <a:solidFill>
-                  <a:srgbClr val="192D3E"/>
-                </a:solidFill>
-                <a:latin typeface="Arial"/>
-              </a:rPr>
-              <a:t>.</a:t>
-            </a:r>
-          </a:p>
-        </p:txBody>
-      </p:sp>
-      <p:sp>
-        <p:nvSpPr>
-          <p:cNvPr id="20" name="TextBox 19"/>
-          <p:cNvSpPr txBox="1"/>
-          <p:nvPr/>
-        </p:nvSpPr>
-        <p:spPr>
-          <a:xfrm>
-            <a:off x="8229600" y="5102352"/>
-            <a:ext cx="2971800" cy="502920"/>
-          </a:xfrm>
-          <a:prstGeom prst="rect">
-            <a:avLst/>
-          </a:prstGeom>
-          <a:noFill/>
-        </p:spPr>
-        <p:txBody>
-          <a:bodyPr wrap="square">
-            <a:normAutofit/>
-          </a:bodyPr>
-          <a:lstStyle/>
-          <a:p>
-            <a:pPr algn="ctr"/>
-            <a:r>
-              <a:rPr sz="1000" b="0">
+              <a:rPr sz="800" b="0">
                 <a:solidFill>
                   <a:srgbClr val="66707A"/>
                 </a:solidFill>
                 <a:latin typeface="Arial"/>
               </a:rPr>
-              <a:t>Evidència: l'informe AGAUR acredita refactorització SOAP cap a REST i reducció d'acoblament.</a:t>
-            </a:r>
-          </a:p>
-        </p:txBody>
-      </p:sp>
-      <p:sp>
-        <p:nvSpPr>
-          <p:cNvPr id="21" name="TextBox 20"/>
-          <p:cNvSpPr txBox="1"/>
-          <p:nvPr/>
-        </p:nvSpPr>
-        <p:spPr>
-          <a:xfrm>
-            <a:off x="594360" y="6473952"/>
-            <a:ext cx="8595360" cy="201168"/>
-          </a:xfrm>
-          <a:prstGeom prst="rect">
-            <a:avLst/>
-          </a:prstGeom>
-          <a:noFill/>
-        </p:spPr>
-        <p:txBody>
-          <a:bodyPr wrap="square">
-            <a:normAutofit/>
-          </a:bodyPr>
-          <a:lstStyle/>
-          <a:p>
-            <a:pPr algn="l"/>
-            <a:r>
-              <a:rPr sz="800" b="0">
-                <a:solidFill>
-                  <a:srgbClr val="66707A"/>
-                </a:solidFill>
-                <a:latin typeface="Arial"/>
-              </a:rPr>
               <a:t>Disseny de Sistemes d'Informació · Ports de sortida en arquitectura hexagonal</a:t>
             </a:r>
           </a:p>
@@ -6779,7 +6804,7 @@
       </p:sp>
       <p:sp>
         <p:nvSpPr>
-          <p:cNvPr id="22" name="TextBox 21"/>
+          <p:cNvPr id="12" name="TextBox 11"/>
           <p:cNvSpPr txBox="1"/>
           <p:nvPr/>
         </p:nvSpPr>
@@ -6867,14 +6892,49 @@
                 </a:solidFill>
                 <a:latin typeface="Arial"/>
               </a:rPr>
-              <a:t>Solució AGAUR: port de sortida i adaptador</a:t>
+              <a:t>Quan l'acoblament es fa risc d'evolució</a:t>
+            </a:r>
+          </a:p>
+        </p:txBody>
+      </p:sp>
+      <p:sp>
+        <p:nvSpPr>
+          <p:cNvPr id="3" name="TextBox 2"/>
+          <p:cNvSpPr txBox="1"/>
+          <p:nvPr/>
+        </p:nvSpPr>
+        <p:spPr>
+          <a:xfrm>
+            <a:off x="612648" y="822960"/>
+            <a:ext cx="8869680" cy="320040"/>
+          </a:xfrm>
+          <a:prstGeom prst="rect">
+            <a:avLst/>
+          </a:prstGeom>
+          <a:noFill/>
+        </p:spPr>
+        <p:txBody>
+          <a:bodyPr wrap="square">
+            <a:normAutofit/>
+          </a:bodyPr>
+          <a:lstStyle/>
+          <a:p>
+            <a:pPr algn="l"/>
+            <a:r>
+              <a:rPr sz="1300" b="0">
+                <a:solidFill>
+                  <a:srgbClr val="66707A"/>
+                </a:solidFill>
+                <a:latin typeface="Arial"/>
+              </a:rPr>
+              <a:t>Lectura institucional prudent: PICA, web services i orientació CTTI cap a APIs</a:t>
             </a:r>
           </a:p>
         </p:txBody>
       </p:sp>
       <p:pic>
         <p:nvPicPr>
-          <p:cNvPr id="3" name="Picture 2" descr="logotip-oficial-tecnocampus-upf-horitzontal-color.png"/>
+          <p:cNvPr id="4" name="Picture 3" descr="logotip-oficial-tecnocampus-upf-horitzontal-color.png"/>
           <p:cNvPicPr>
             <a:picLocks noChangeAspect="1"/>
           </p:cNvPicPr>
@@ -6898,7 +6958,7 @@
       </p:pic>
       <p:sp>
         <p:nvSpPr>
-          <p:cNvPr id="4" name="Rectangle 3"/>
+          <p:cNvPr id="5" name="Rectangle 4"/>
           <p:cNvSpPr/>
           <p:nvPr/>
         </p:nvSpPr>
@@ -6940,30 +7000,6 @@
           </a:p>
         </p:txBody>
       </p:sp>
-      <p:pic>
-        <p:nvPicPr>
-          <p:cNvPr id="5" name="Picture 4" descr="agaur-after-hexagonal.png"/>
-          <p:cNvPicPr>
-            <a:picLocks noChangeAspect="1"/>
-          </p:cNvPicPr>
-          <p:nvPr/>
-        </p:nvPicPr>
-        <p:blipFill>
-          <a:blip r:embed="rId3"/>
-          <a:stretch>
-            <a:fillRect/>
-          </a:stretch>
-        </p:blipFill>
-        <p:spPr>
-          <a:xfrm>
-            <a:off x="685800" y="2511212"/>
-            <a:ext cx="7315200" cy="2475655"/>
-          </a:xfrm>
-          <a:prstGeom prst="rect">
-            <a:avLst/>
-          </a:prstGeom>
-        </p:spPr>
-      </p:pic>
       <p:sp>
         <p:nvSpPr>
           <p:cNvPr id="6" name="TextBox 5"/>
@@ -6972,8 +7008,8 @@
         </p:nvSpPr>
         <p:spPr>
           <a:xfrm>
-            <a:off x="8229600" y="1828800"/>
-            <a:ext cx="2971800" cy="1920240"/>
+            <a:off x="822960" y="1298448"/>
+            <a:ext cx="10424160" cy="320040"/>
           </a:xfrm>
           <a:prstGeom prst="rect">
             <a:avLst/>
@@ -6986,30 +7022,75 @@
           </a:bodyPr>
           <a:lstStyle/>
           <a:p>
-            <a:pPr algn="l"/>
-            <a:r>
-              <a:rPr sz="2100" b="1">
+            <a:pPr algn="ctr"/>
+            <a:r>
+              <a:rPr sz="1600" b="1">
                 <a:solidFill>
                   <a:srgbClr val="192D3E"/>
                 </a:solidFill>
                 <a:latin typeface="Arial"/>
               </a:rPr>
-              <a:t>El port defineix què necessita l'aplicació.
-L'adaptador resol com obtenir-ho amb una tecnologia concreta.</a:t>
-            </a:r>
-          </a:p>
-        </p:txBody>
-      </p:sp>
-      <p:sp>
-        <p:nvSpPr>
-          <p:cNvPr id="7" name="TextBox 6"/>
+              <a:t>La qüestió no és predir l'evolució concreta de SOAP: és que cap tecnologia d'integració ha d'arrossegar el procediment.</a:t>
+            </a:r>
+          </a:p>
+        </p:txBody>
+      </p:sp>
+      <p:sp>
+        <p:nvSpPr>
+          <p:cNvPr id="7" name="Rectangle 6"/>
+          <p:cNvSpPr/>
+          <p:nvPr/>
+        </p:nvSpPr>
+        <p:spPr>
+          <a:xfrm>
+            <a:off x="777240" y="1783080"/>
+            <a:ext cx="3246120" cy="2971800"/>
+          </a:xfrm>
+          <a:prstGeom prst="rect">
+            <a:avLst/>
+          </a:prstGeom>
+          <a:solidFill>
+            <a:srgbClr val="F8EAEA"/>
+          </a:solidFill>
+          <a:ln w="9525">
+            <a:solidFill>
+              <a:srgbClr val="DCE0E4"/>
+            </a:solidFill>
+          </a:ln>
+        </p:spPr>
+        <p:style>
+          <a:lnRef idx="1">
+            <a:schemeClr val="accent1"/>
+          </a:lnRef>
+          <a:fillRef idx="3">
+            <a:schemeClr val="accent1"/>
+          </a:fillRef>
+          <a:effectRef idx="2">
+            <a:schemeClr val="accent1"/>
+          </a:effectRef>
+          <a:fontRef idx="minor">
+            <a:schemeClr val="lt1"/>
+          </a:fontRef>
+        </p:style>
+        <p:txBody>
+          <a:bodyPr rtlCol="0" anchor="ctr"/>
+          <a:lstStyle/>
+          <a:p>
+            <a:pPr algn="ctr"/>
+            <a:endParaRPr/>
+          </a:p>
+        </p:txBody>
+      </p:sp>
+      <p:sp>
+        <p:nvSpPr>
+          <p:cNvPr id="8" name="TextBox 7"/>
           <p:cNvSpPr txBox="1"/>
           <p:nvPr/>
         </p:nvSpPr>
         <p:spPr>
           <a:xfrm>
-            <a:off x="8229600" y="4160520"/>
-            <a:ext cx="2971800" cy="822960"/>
+            <a:off x="1005840" y="2011680"/>
+            <a:ext cx="2788920" cy="292608"/>
           </a:xfrm>
           <a:prstGeom prst="rect">
             <a:avLst/>
@@ -7022,29 +7103,29 @@
           </a:bodyPr>
           <a:lstStyle/>
           <a:p>
-            <a:pPr algn="l"/>
-            <a:r>
-              <a:rPr sz="1700" b="0">
-                <a:solidFill>
-                  <a:srgbClr val="236092"/>
-                </a:solidFill>
-                <a:latin typeface="Arial"/>
-              </a:rPr>
-              <a:t>El cas d'ús necessita una capacitat externa, no una tecnologia externa concreta.</a:t>
-            </a:r>
-          </a:p>
-        </p:txBody>
-      </p:sp>
-      <p:sp>
-        <p:nvSpPr>
-          <p:cNvPr id="8" name="TextBox 7"/>
+            <a:pPr algn="ctr"/>
+            <a:r>
+              <a:rPr sz="1800" b="1">
+                <a:solidFill>
+                  <a:srgbClr val="192D3E"/>
+                </a:solidFill>
+                <a:latin typeface="Arial"/>
+              </a:rPr>
+              <a:t>Situació verificable</a:t>
+            </a:r>
+          </a:p>
+        </p:txBody>
+      </p:sp>
+      <p:sp>
+        <p:nvSpPr>
+          <p:cNvPr id="9" name="TextBox 8"/>
           <p:cNvSpPr txBox="1"/>
           <p:nvPr/>
         </p:nvSpPr>
         <p:spPr>
           <a:xfrm>
-            <a:off x="594360" y="6473952"/>
-            <a:ext cx="8595360" cy="201168"/>
+            <a:off x="1024128" y="2487168"/>
+            <a:ext cx="2788920" cy="640080"/>
           </a:xfrm>
           <a:prstGeom prst="rect">
             <a:avLst/>
@@ -7057,8 +7138,488 @@
           </a:bodyPr>
           <a:lstStyle/>
           <a:p>
+            <a:pPr algn="ctr"/>
+            <a:r>
+              <a:rPr sz="1600" b="1">
+                <a:solidFill>
+                  <a:srgbClr val="192D3E"/>
+                </a:solidFill>
+                <a:latin typeface="Arial"/>
+              </a:rPr>
+              <a:t>PICA continua essent una plataforma corporativa d'interoperabilitat.</a:t>
+            </a:r>
+          </a:p>
+        </p:txBody>
+      </p:sp>
+      <p:sp>
+        <p:nvSpPr>
+          <p:cNvPr id="10" name="TextBox 9"/>
+          <p:cNvSpPr txBox="1"/>
+          <p:nvPr/>
+        </p:nvSpPr>
+        <p:spPr>
+          <a:xfrm>
+            <a:off x="1024128" y="3364992"/>
+            <a:ext cx="2788920" cy="640080"/>
+          </a:xfrm>
+          <a:prstGeom prst="rect">
+            <a:avLst/>
+          </a:prstGeom>
+          <a:noFill/>
+        </p:spPr>
+        <p:txBody>
+          <a:bodyPr wrap="square">
+            <a:normAutofit/>
+          </a:bodyPr>
+          <a:lstStyle/>
+          <a:p>
+            <a:pPr algn="ctr"/>
+            <a:r>
+              <a:rPr sz="1400" b="0">
+                <a:solidFill>
+                  <a:srgbClr val="262626"/>
+                </a:solidFill>
+                <a:latin typeface="Arial"/>
+              </a:rPr>
+              <a:t>La documentació pública mostra integració amb web services i antecedents SOAP.</a:t>
+            </a:r>
+          </a:p>
+        </p:txBody>
+      </p:sp>
+      <p:sp>
+        <p:nvSpPr>
+          <p:cNvPr id="11" name="TextBox 10"/>
+          <p:cNvSpPr txBox="1"/>
+          <p:nvPr/>
+        </p:nvSpPr>
+        <p:spPr>
+          <a:xfrm>
+            <a:off x="1024128" y="4114800"/>
+            <a:ext cx="2788920" cy="320040"/>
+          </a:xfrm>
+          <a:prstGeom prst="rect">
+            <a:avLst/>
+          </a:prstGeom>
+          <a:noFill/>
+        </p:spPr>
+        <p:txBody>
+          <a:bodyPr wrap="square">
+            <a:normAutofit/>
+          </a:bodyPr>
+          <a:lstStyle/>
+          <a:p>
+            <a:pPr algn="ctr"/>
+            <a:r>
+              <a:rPr sz="1700" b="1">
+                <a:solidFill>
+                  <a:srgbClr val="236092"/>
+                </a:solidFill>
+                <a:latin typeface="Arial"/>
+              </a:rPr>
+              <a:t>PICA / web services</a:t>
+            </a:r>
+          </a:p>
+        </p:txBody>
+      </p:sp>
+      <p:sp>
+        <p:nvSpPr>
+          <p:cNvPr id="12" name="Rectangle 11"/>
+          <p:cNvSpPr/>
+          <p:nvPr/>
+        </p:nvSpPr>
+        <p:spPr>
+          <a:xfrm>
+            <a:off x="4434840" y="1783080"/>
+            <a:ext cx="3246120" cy="2971800"/>
+          </a:xfrm>
+          <a:prstGeom prst="rect">
+            <a:avLst/>
+          </a:prstGeom>
+          <a:solidFill>
+            <a:srgbClr val="FFF3D6"/>
+          </a:solidFill>
+          <a:ln w="9525">
+            <a:solidFill>
+              <a:srgbClr val="DCE0E4"/>
+            </a:solidFill>
+          </a:ln>
+        </p:spPr>
+        <p:style>
+          <a:lnRef idx="1">
+            <a:schemeClr val="accent1"/>
+          </a:lnRef>
+          <a:fillRef idx="3">
+            <a:schemeClr val="accent1"/>
+          </a:fillRef>
+          <a:effectRef idx="2">
+            <a:schemeClr val="accent1"/>
+          </a:effectRef>
+          <a:fontRef idx="minor">
+            <a:schemeClr val="lt1"/>
+          </a:fontRef>
+        </p:style>
+        <p:txBody>
+          <a:bodyPr rtlCol="0" anchor="ctr"/>
+          <a:lstStyle/>
+          <a:p>
+            <a:pPr algn="ctr"/>
+            <a:endParaRPr/>
+          </a:p>
+        </p:txBody>
+      </p:sp>
+      <p:sp>
+        <p:nvSpPr>
+          <p:cNvPr id="13" name="TextBox 12"/>
+          <p:cNvSpPr txBox="1"/>
+          <p:nvPr/>
+        </p:nvSpPr>
+        <p:spPr>
+          <a:xfrm>
+            <a:off x="4663440" y="2011680"/>
+            <a:ext cx="2788920" cy="292608"/>
+          </a:xfrm>
+          <a:prstGeom prst="rect">
+            <a:avLst/>
+          </a:prstGeom>
+          <a:noFill/>
+        </p:spPr>
+        <p:txBody>
+          <a:bodyPr wrap="square">
+            <a:normAutofit/>
+          </a:bodyPr>
+          <a:lstStyle/>
+          <a:p>
+            <a:pPr algn="ctr"/>
+            <a:r>
+              <a:rPr sz="1800" b="1">
+                <a:solidFill>
+                  <a:srgbClr val="192D3E"/>
+                </a:solidFill>
+                <a:latin typeface="Arial"/>
+              </a:rPr>
+              <a:t>Risc arquitectònic</a:t>
+            </a:r>
+          </a:p>
+        </p:txBody>
+      </p:sp>
+      <p:sp>
+        <p:nvSpPr>
+          <p:cNvPr id="14" name="TextBox 13"/>
+          <p:cNvSpPr txBox="1"/>
+          <p:nvPr/>
+        </p:nvSpPr>
+        <p:spPr>
+          <a:xfrm>
+            <a:off x="4681728" y="2514600"/>
+            <a:ext cx="2788920" cy="1737360"/>
+          </a:xfrm>
+          <a:prstGeom prst="rect">
+            <a:avLst/>
+          </a:prstGeom>
+          <a:noFill/>
+        </p:spPr>
+        <p:txBody>
+          <a:bodyPr wrap="square">
+            <a:normAutofit/>
+          </a:bodyPr>
+          <a:lstStyle/>
+          <a:p>
+            <a:pPr>
+              <a:spcAft>
+                <a:spcPts val="800"/>
+              </a:spcAft>
+              <a:defRPr sz="1200">
+                <a:solidFill>
+                  <a:srgbClr val="262626"/>
+                </a:solidFill>
+                <a:latin typeface="Arial"/>
+              </a:defRPr>
+            </a:pPr>
+            <a:r>
+              <a:t>El flux de l'expedient coneix PICA, SOAP/XML, DTOs, mapping i errors tècnics.</a:t>
+            </a:r>
+          </a:p>
+          <a:p>
+            <a:pPr>
+              <a:spcAft>
+                <a:spcPts val="800"/>
+              </a:spcAft>
+              <a:defRPr sz="1200">
+                <a:solidFill>
+                  <a:srgbClr val="262626"/>
+                </a:solidFill>
+                <a:latin typeface="Arial"/>
+              </a:defRPr>
+            </a:pPr>
+            <a:r>
+              <a:t>La lògica administrativa depèn d'una tecnologia d'integració concreta.</a:t>
+            </a:r>
+          </a:p>
+          <a:p>
+            <a:pPr>
+              <a:spcAft>
+                <a:spcPts val="800"/>
+              </a:spcAft>
+              <a:defRPr sz="1200">
+                <a:solidFill>
+                  <a:srgbClr val="262626"/>
+                </a:solidFill>
+                <a:latin typeface="Arial"/>
+              </a:defRPr>
+            </a:pPr>
+            <a:r>
+              <a:t>Qualsevol evolució cap a REST, API Manager o EventHub impacta massa capes.</a:t>
+            </a:r>
+          </a:p>
+        </p:txBody>
+      </p:sp>
+      <p:sp>
+        <p:nvSpPr>
+          <p:cNvPr id="15" name="Rectangle 14"/>
+          <p:cNvSpPr/>
+          <p:nvPr/>
+        </p:nvSpPr>
+        <p:spPr>
+          <a:xfrm>
+            <a:off x="8092440" y="1783080"/>
+            <a:ext cx="3246120" cy="2971800"/>
+          </a:xfrm>
+          <a:prstGeom prst="rect">
+            <a:avLst/>
+          </a:prstGeom>
+          <a:solidFill>
+            <a:srgbClr val="E8F1F8"/>
+          </a:solidFill>
+          <a:ln w="9525">
+            <a:solidFill>
+              <a:srgbClr val="DCE0E4"/>
+            </a:solidFill>
+          </a:ln>
+        </p:spPr>
+        <p:style>
+          <a:lnRef idx="1">
+            <a:schemeClr val="accent1"/>
+          </a:lnRef>
+          <a:fillRef idx="3">
+            <a:schemeClr val="accent1"/>
+          </a:fillRef>
+          <a:effectRef idx="2">
+            <a:schemeClr val="accent1"/>
+          </a:effectRef>
+          <a:fontRef idx="minor">
+            <a:schemeClr val="lt1"/>
+          </a:fontRef>
+        </p:style>
+        <p:txBody>
+          <a:bodyPr rtlCol="0" anchor="ctr"/>
+          <a:lstStyle/>
+          <a:p>
+            <a:pPr algn="ctr"/>
+            <a:endParaRPr/>
+          </a:p>
+        </p:txBody>
+      </p:sp>
+      <p:sp>
+        <p:nvSpPr>
+          <p:cNvPr id="16" name="TextBox 15"/>
+          <p:cNvSpPr txBox="1"/>
+          <p:nvPr/>
+        </p:nvSpPr>
+        <p:spPr>
+          <a:xfrm>
+            <a:off x="8321040" y="2011680"/>
+            <a:ext cx="2788920" cy="292608"/>
+          </a:xfrm>
+          <a:prstGeom prst="rect">
+            <a:avLst/>
+          </a:prstGeom>
+          <a:noFill/>
+        </p:spPr>
+        <p:txBody>
+          <a:bodyPr wrap="square">
+            <a:normAutofit/>
+          </a:bodyPr>
+          <a:lstStyle/>
+          <a:p>
+            <a:pPr algn="ctr"/>
+            <a:r>
+              <a:rPr sz="1800" b="1">
+                <a:solidFill>
+                  <a:srgbClr val="192D3E"/>
+                </a:solidFill>
+                <a:latin typeface="Arial"/>
+              </a:rPr>
+              <a:t>Criteri docent</a:t>
+            </a:r>
+          </a:p>
+        </p:txBody>
+      </p:sp>
+      <p:sp>
+        <p:nvSpPr>
+          <p:cNvPr id="17" name="TextBox 16"/>
+          <p:cNvSpPr txBox="1"/>
+          <p:nvPr/>
+        </p:nvSpPr>
+        <p:spPr>
+          <a:xfrm>
+            <a:off x="8339327" y="2542032"/>
+            <a:ext cx="2788920" cy="685800"/>
+          </a:xfrm>
+          <a:prstGeom prst="rect">
+            <a:avLst/>
+          </a:prstGeom>
+          <a:noFill/>
+        </p:spPr>
+        <p:txBody>
+          <a:bodyPr wrap="square">
+            <a:normAutofit/>
+          </a:bodyPr>
+          <a:lstStyle/>
+          <a:p>
+            <a:pPr algn="ctr"/>
+            <a:r>
+              <a:rPr sz="1600" b="1">
+                <a:solidFill>
+                  <a:srgbClr val="192D3E"/>
+                </a:solidFill>
+                <a:latin typeface="Arial"/>
+              </a:rPr>
+              <a:t>Separar criteris del procediment, casos d'ús i infraestructura.</a:t>
+            </a:r>
+          </a:p>
+        </p:txBody>
+      </p:sp>
+      <p:sp>
+        <p:nvSpPr>
+          <p:cNvPr id="18" name="TextBox 17"/>
+          <p:cNvSpPr txBox="1"/>
+          <p:nvPr/>
+        </p:nvSpPr>
+        <p:spPr>
+          <a:xfrm>
+            <a:off x="8339327" y="3474720"/>
+            <a:ext cx="2788920" cy="777240"/>
+          </a:xfrm>
+          <a:prstGeom prst="rect">
+            <a:avLst/>
+          </a:prstGeom>
+          <a:noFill/>
+        </p:spPr>
+        <p:txBody>
+          <a:bodyPr wrap="square">
+            <a:normAutofit/>
+          </a:bodyPr>
+          <a:lstStyle/>
+          <a:p>
+            <a:pPr algn="ctr"/>
+            <a:r>
+              <a:rPr sz="1800" b="1">
+                <a:solidFill>
+                  <a:srgbClr val="236092"/>
+                </a:solidFill>
+                <a:latin typeface="Arial"/>
+              </a:rPr>
+              <a:t>Port de sortida
++
+adaptadors substituïbles</a:t>
+            </a:r>
+          </a:p>
+        </p:txBody>
+      </p:sp>
+      <p:sp>
+        <p:nvSpPr>
+          <p:cNvPr id="19" name="TextBox 18"/>
+          <p:cNvSpPr txBox="1"/>
+          <p:nvPr/>
+        </p:nvSpPr>
+        <p:spPr>
+          <a:xfrm>
+            <a:off x="1051560" y="5074920"/>
+            <a:ext cx="6949440" cy="566928"/>
+          </a:xfrm>
+          <a:prstGeom prst="rect">
+            <a:avLst/>
+          </a:prstGeom>
+          <a:noFill/>
+        </p:spPr>
+        <p:txBody>
+          <a:bodyPr wrap="square">
+            <a:normAutofit/>
+          </a:bodyPr>
+          <a:lstStyle/>
+          <a:p>
             <a:pPr algn="l"/>
             <a:r>
+              <a:rPr sz="1700" b="1">
+                <a:solidFill>
+                  <a:srgbClr val="192D3E"/>
+                </a:solidFill>
+                <a:latin typeface="Arial"/>
+              </a:rPr>
+              <a:t>El motiu arquitectònic no és només "fer REST": és evitar que l'evolució tecnològica arrossegui els casos d'ús.</a:t>
+            </a:r>
+          </a:p>
+        </p:txBody>
+      </p:sp>
+      <p:sp>
+        <p:nvSpPr>
+          <p:cNvPr id="20" name="TextBox 19"/>
+          <p:cNvSpPr txBox="1"/>
+          <p:nvPr/>
+        </p:nvSpPr>
+        <p:spPr>
+          <a:xfrm>
+            <a:off x="8229600" y="5102352"/>
+            <a:ext cx="2971800" cy="502920"/>
+          </a:xfrm>
+          <a:prstGeom prst="rect">
+            <a:avLst/>
+          </a:prstGeom>
+          <a:noFill/>
+        </p:spPr>
+        <p:txBody>
+          <a:bodyPr wrap="square">
+            <a:normAutofit/>
+          </a:bodyPr>
+          <a:lstStyle/>
+          <a:p>
+            <a:pPr algn="ctr"/>
+            <a:r>
+              <a:rPr sz="1000" b="0">
+                <a:solidFill>
+                  <a:srgbClr val="66707A"/>
+                </a:solidFill>
+                <a:latin typeface="Arial"/>
+              </a:rPr>
+              <a:t>Evidència: l'informe AGAUR acredita refactorització SOAP cap a REST i reducció d'acoblament.</a:t>
+            </a:r>
+          </a:p>
+        </p:txBody>
+      </p:sp>
+      <p:sp>
+        <p:nvSpPr>
+          <p:cNvPr id="21" name="TextBox 20"/>
+          <p:cNvSpPr txBox="1"/>
+          <p:nvPr/>
+        </p:nvSpPr>
+        <p:spPr>
+          <a:xfrm>
+            <a:off x="594360" y="6473952"/>
+            <a:ext cx="8595360" cy="201168"/>
+          </a:xfrm>
+          <a:prstGeom prst="rect">
+            <a:avLst/>
+          </a:prstGeom>
+          <a:noFill/>
+        </p:spPr>
+        <p:txBody>
+          <a:bodyPr wrap="square">
+            <a:normAutofit/>
+          </a:bodyPr>
+          <a:lstStyle/>
+          <a:p>
+            <a:pPr algn="l"/>
+            <a:r>
               <a:rPr sz="800" b="0">
                 <a:solidFill>
                   <a:srgbClr val="66707A"/>
@@ -7072,7 +7633,7 @@
       </p:sp>
       <p:sp>
         <p:nvSpPr>
-          <p:cNvPr id="9" name="TextBox 8"/>
+          <p:cNvPr id="22" name="TextBox 21"/>
           <p:cNvSpPr txBox="1"/>
           <p:nvPr/>
         </p:nvSpPr>
@@ -7160,49 +7721,14 @@
                 </a:solidFill>
                 <a:latin typeface="Arial"/>
               </a:rPr>
-              <a:t>De la interface al port</a:t>
-            </a:r>
-          </a:p>
-        </p:txBody>
-      </p:sp>
-      <p:sp>
-        <p:nvSpPr>
-          <p:cNvPr id="3" name="TextBox 2"/>
-          <p:cNvSpPr txBox="1"/>
-          <p:nvPr/>
-        </p:nvSpPr>
-        <p:spPr>
-          <a:xfrm>
-            <a:off x="612648" y="822960"/>
-            <a:ext cx="8869680" cy="320040"/>
-          </a:xfrm>
-          <a:prstGeom prst="rect">
-            <a:avLst/>
-          </a:prstGeom>
-          <a:noFill/>
-        </p:spPr>
-        <p:txBody>
-          <a:bodyPr wrap="square">
-            <a:normAutofit/>
-          </a:bodyPr>
-          <a:lstStyle/>
-          <a:p>
-            <a:pPr algn="l"/>
-            <a:r>
-              <a:rPr sz="1300" b="0">
-                <a:solidFill>
-                  <a:srgbClr val="66707A"/>
-                </a:solidFill>
-                <a:latin typeface="Arial"/>
-              </a:rPr>
-              <a:t>Una frontera arquitectònica, no només un contracte Java</a:t>
+              <a:t>Solució AGAUR: port de sortida i adaptador</a:t>
             </a:r>
           </a:p>
         </p:txBody>
       </p:sp>
       <p:pic>
         <p:nvPicPr>
-          <p:cNvPr id="4" name="Picture 3" descr="logotip-oficial-tecnocampus-upf-horitzontal-color.png"/>
+          <p:cNvPr id="3" name="Picture 2" descr="logotip-oficial-tecnocampus-upf-horitzontal-color.png"/>
           <p:cNvPicPr>
             <a:picLocks noChangeAspect="1"/>
           </p:cNvPicPr>
@@ -7226,7 +7752,7 @@
       </p:pic>
       <p:sp>
         <p:nvSpPr>
-          <p:cNvPr id="5" name="Rectangle 4"/>
+          <p:cNvPr id="4" name="Rectangle 3"/>
           <p:cNvSpPr/>
           <p:nvPr/>
         </p:nvSpPr>
@@ -7270,7 +7796,7 @@
       </p:sp>
       <p:pic>
         <p:nvPicPr>
-          <p:cNvPr id="6" name="Picture 5" descr="output-port-pattern.png"/>
+          <p:cNvPr id="5" name="Picture 4" descr="agaur-after-hexagonal.png"/>
           <p:cNvPicPr>
             <a:picLocks noChangeAspect="1"/>
           </p:cNvPicPr>
@@ -7284,8 +7810,8 @@
         </p:blipFill>
         <p:spPr>
           <a:xfrm>
-            <a:off x="685800" y="2281557"/>
-            <a:ext cx="6766560" cy="2889246"/>
+            <a:off x="685800" y="2511212"/>
+            <a:ext cx="7315200" cy="2475655"/>
           </a:xfrm>
           <a:prstGeom prst="rect">
             <a:avLst/>
@@ -7294,60 +7820,14 @@
       </p:pic>
       <p:sp>
         <p:nvSpPr>
-          <p:cNvPr id="7" name="Rounded Rectangle 6"/>
-          <p:cNvSpPr/>
-          <p:nvPr/>
-        </p:nvSpPr>
-        <p:spPr>
-          <a:xfrm>
-            <a:off x="7726679" y="1600200"/>
-            <a:ext cx="3337560" cy="3474720"/>
-          </a:xfrm>
-          <a:prstGeom prst="roundRect">
-            <a:avLst/>
-          </a:prstGeom>
-          <a:solidFill>
-            <a:srgbClr val="F7F8FA"/>
-          </a:solidFill>
-          <a:ln w="9525">
-            <a:solidFill>
-              <a:srgbClr val="DCE0E4"/>
-            </a:solidFill>
-          </a:ln>
-        </p:spPr>
-        <p:style>
-          <a:lnRef idx="1">
-            <a:schemeClr val="accent1"/>
-          </a:lnRef>
-          <a:fillRef idx="3">
-            <a:schemeClr val="accent1"/>
-          </a:fillRef>
-          <a:effectRef idx="2">
-            <a:schemeClr val="accent1"/>
-          </a:effectRef>
-          <a:fontRef idx="minor">
-            <a:schemeClr val="lt1"/>
-          </a:fontRef>
-        </p:style>
-        <p:txBody>
-          <a:bodyPr rtlCol="0" anchor="ctr"/>
-          <a:lstStyle/>
-          <a:p>
-            <a:pPr algn="ctr"/>
-            <a:endParaRPr/>
-          </a:p>
-        </p:txBody>
-      </p:sp>
-      <p:sp>
-        <p:nvSpPr>
-          <p:cNvPr id="8" name="TextBox 7"/>
+          <p:cNvPr id="6" name="TextBox 5"/>
           <p:cNvSpPr txBox="1"/>
           <p:nvPr/>
         </p:nvSpPr>
         <p:spPr>
           <a:xfrm>
-            <a:off x="8001000" y="2011680"/>
-            <a:ext cx="2788920" cy="2194560"/>
+            <a:off x="8229600" y="1828800"/>
+            <a:ext cx="2971800" cy="1920240"/>
           </a:xfrm>
           <a:prstGeom prst="rect">
             <a:avLst/>
@@ -7360,30 +7840,30 @@
           </a:bodyPr>
           <a:lstStyle/>
           <a:p>
-            <a:pPr algn="ctr"/>
-            <a:r>
-              <a:rPr sz="2200" b="1">
+            <a:pPr algn="l"/>
+            <a:r>
+              <a:rPr sz="2100" b="1">
                 <a:solidFill>
                   <a:srgbClr val="192D3E"/>
                 </a:solidFill>
                 <a:latin typeface="Arial"/>
               </a:rPr>
-              <a:t>Una interface pot desacoblar dues classes.
-Un port de sortida defineix una frontera arquitectònica.</a:t>
-            </a:r>
-          </a:p>
-        </p:txBody>
-      </p:sp>
-      <p:sp>
-        <p:nvSpPr>
-          <p:cNvPr id="9" name="TextBox 8"/>
+              <a:t>El port defineix què necessita l'aplicació.
+L'adaptador resol com obtenir-ho amb una tecnologia concreta.</a:t>
+            </a:r>
+          </a:p>
+        </p:txBody>
+      </p:sp>
+      <p:sp>
+        <p:nvSpPr>
+          <p:cNvPr id="7" name="TextBox 6"/>
           <p:cNvSpPr txBox="1"/>
           <p:nvPr/>
         </p:nvSpPr>
         <p:spPr>
           <a:xfrm>
-            <a:off x="594360" y="6473952"/>
-            <a:ext cx="8595360" cy="201168"/>
+            <a:off x="8229600" y="4160520"/>
+            <a:ext cx="2971800" cy="822960"/>
           </a:xfrm>
           <a:prstGeom prst="rect">
             <a:avLst/>
@@ -7398,6 +7878,41 @@
           <a:p>
             <a:pPr algn="l"/>
             <a:r>
+              <a:rPr sz="1700" b="0">
+                <a:solidFill>
+                  <a:srgbClr val="236092"/>
+                </a:solidFill>
+                <a:latin typeface="Arial"/>
+              </a:rPr>
+              <a:t>El cas d'ús necessita una capacitat externa, no una tecnologia externa concreta.</a:t>
+            </a:r>
+          </a:p>
+        </p:txBody>
+      </p:sp>
+      <p:sp>
+        <p:nvSpPr>
+          <p:cNvPr id="8" name="TextBox 7"/>
+          <p:cNvSpPr txBox="1"/>
+          <p:nvPr/>
+        </p:nvSpPr>
+        <p:spPr>
+          <a:xfrm>
+            <a:off x="594360" y="6473952"/>
+            <a:ext cx="8595360" cy="201168"/>
+          </a:xfrm>
+          <a:prstGeom prst="rect">
+            <a:avLst/>
+          </a:prstGeom>
+          <a:noFill/>
+        </p:spPr>
+        <p:txBody>
+          <a:bodyPr wrap="square">
+            <a:normAutofit/>
+          </a:bodyPr>
+          <a:lstStyle/>
+          <a:p>
+            <a:pPr algn="l"/>
+            <a:r>
               <a:rPr sz="800" b="0">
                 <a:solidFill>
                   <a:srgbClr val="66707A"/>
@@ -7411,7 +7926,7 @@
       </p:sp>
       <p:sp>
         <p:nvSpPr>
-          <p:cNvPr id="10" name="TextBox 9"/>
+          <p:cNvPr id="9" name="TextBox 8"/>
           <p:cNvSpPr txBox="1"/>
           <p:nvPr/>
         </p:nvSpPr>
@@ -7499,7 +8014,7 @@
                 </a:solidFill>
                 <a:latin typeface="Arial"/>
               </a:rPr>
-              <a:t>Transferència a HexaStock</a:t>
+              <a:t>De la interface al port</a:t>
             </a:r>
           </a:p>
         </p:txBody>
@@ -7534,7 +8049,7 @@
                 </a:solidFill>
                 <a:latin typeface="Arial"/>
               </a:rPr>
-              <a:t>Venda d'accions amb proveïdor de preus substituïble</a:t>
+              <a:t>Una frontera arquitectònica, no només un contracte Java</a:t>
             </a:r>
           </a:p>
         </p:txBody>
@@ -7609,7 +8124,7 @@
       </p:sp>
       <p:pic>
         <p:nvPicPr>
-          <p:cNvPr id="6" name="Picture 5" descr="hexastock-sellstocks-arquitectura-vpd.png"/>
+          <p:cNvPr id="6" name="Picture 5" descr="output-port-pattern.png"/>
           <p:cNvPicPr>
             <a:picLocks noChangeAspect="1"/>
           </p:cNvPicPr>
@@ -7623,8 +8138,8 @@
         </p:blipFill>
         <p:spPr>
           <a:xfrm>
-            <a:off x="502920" y="1600138"/>
-            <a:ext cx="7818120" cy="4389244"/>
+            <a:off x="685800" y="2281557"/>
+            <a:ext cx="6766560" cy="2889246"/>
           </a:xfrm>
           <a:prstGeom prst="rect">
             <a:avLst/>
@@ -7633,14 +8148,60 @@
       </p:pic>
       <p:sp>
         <p:nvSpPr>
-          <p:cNvPr id="7" name="TextBox 6"/>
+          <p:cNvPr id="7" name="Rounded Rectangle 6"/>
+          <p:cNvSpPr/>
+          <p:nvPr/>
+        </p:nvSpPr>
+        <p:spPr>
+          <a:xfrm>
+            <a:off x="7726679" y="1600200"/>
+            <a:ext cx="3337560" cy="3474720"/>
+          </a:xfrm>
+          <a:prstGeom prst="roundRect">
+            <a:avLst/>
+          </a:prstGeom>
+          <a:solidFill>
+            <a:srgbClr val="F7F8FA"/>
+          </a:solidFill>
+          <a:ln w="9525">
+            <a:solidFill>
+              <a:srgbClr val="DCE0E4"/>
+            </a:solidFill>
+          </a:ln>
+        </p:spPr>
+        <p:style>
+          <a:lnRef idx="1">
+            <a:schemeClr val="accent1"/>
+          </a:lnRef>
+          <a:fillRef idx="3">
+            <a:schemeClr val="accent1"/>
+          </a:fillRef>
+          <a:effectRef idx="2">
+            <a:schemeClr val="accent1"/>
+          </a:effectRef>
+          <a:fontRef idx="minor">
+            <a:schemeClr val="lt1"/>
+          </a:fontRef>
+        </p:style>
+        <p:txBody>
+          <a:bodyPr rtlCol="0" anchor="ctr"/>
+          <a:lstStyle/>
+          <a:p>
+            <a:pPr algn="ctr"/>
+            <a:endParaRPr/>
+          </a:p>
+        </p:txBody>
+      </p:sp>
+      <p:sp>
+        <p:nvSpPr>
+          <p:cNvPr id="8" name="TextBox 7"/>
           <p:cNvSpPr txBox="1"/>
           <p:nvPr/>
         </p:nvSpPr>
         <p:spPr>
           <a:xfrm>
-            <a:off x="8549640" y="1600200"/>
-            <a:ext cx="2743200" cy="2011680"/>
+            <a:off x="8001000" y="2011680"/>
+            <a:ext cx="2788920" cy="2194560"/>
           </a:xfrm>
           <a:prstGeom prst="rect">
             <a:avLst/>
@@ -7653,29 +8214,30 @@
           </a:bodyPr>
           <a:lstStyle/>
           <a:p>
-            <a:pPr algn="l"/>
-            <a:r>
-              <a:rPr sz="1700" b="1">
+            <a:pPr algn="ctr"/>
+            <a:r>
+              <a:rPr sz="2200" b="1">
                 <a:solidFill>
                   <a:srgbClr val="192D3E"/>
                 </a:solidFill>
                 <a:latin typeface="Arial"/>
               </a:rPr>
-              <a:t>El cas d'ús necessita el preu actual d'un ticker, però no ha de dependre de Finnhub, Alpha Vantage, REST, JSON, tokens, endpoints ni clients HTTP.</a:t>
-            </a:r>
-          </a:p>
-        </p:txBody>
-      </p:sp>
-      <p:sp>
-        <p:nvSpPr>
-          <p:cNvPr id="8" name="TextBox 7"/>
+              <a:t>Una interface pot desacoblar dues classes.
+Un port de sortida defineix una frontera arquitectònica.</a:t>
+            </a:r>
+          </a:p>
+        </p:txBody>
+      </p:sp>
+      <p:sp>
+        <p:nvSpPr>
+          <p:cNvPr id="9" name="TextBox 8"/>
           <p:cNvSpPr txBox="1"/>
           <p:nvPr/>
         </p:nvSpPr>
         <p:spPr>
           <a:xfrm>
-            <a:off x="8549640" y="3931920"/>
-            <a:ext cx="2743200" cy="1417320"/>
+            <a:off x="594360" y="6473952"/>
+            <a:ext cx="8595360" cy="201168"/>
           </a:xfrm>
           <a:prstGeom prst="rect">
             <a:avLst/>
@@ -7688,86 +8250,15 @@
           </a:bodyPr>
           <a:lstStyle/>
           <a:p>
-            <a:pPr>
-              <a:spcAft>
-                <a:spcPts val="800"/>
-              </a:spcAft>
-              <a:defRPr sz="1300">
-                <a:solidFill>
-                  <a:srgbClr val="262626"/>
-                </a:solidFill>
-                <a:latin typeface="Arial"/>
-              </a:defRPr>
-            </a:pPr>
-            <a:r>
-              <a:t>Port: StockPriceProviderPort</a:t>
-            </a:r>
-          </a:p>
-          <a:p>
-            <a:pPr>
-              <a:spcAft>
-                <a:spcPts val="800"/>
-              </a:spcAft>
-              <a:defRPr sz="1300">
-                <a:solidFill>
-                  <a:srgbClr val="262626"/>
-                </a:solidFill>
-                <a:latin typeface="Arial"/>
-              </a:defRPr>
-            </a:pPr>
-            <a:r>
-              <a:t>Adaptadors: Finnhub, Alpha Vantage, mock</a:t>
-            </a:r>
-          </a:p>
-          <a:p>
-            <a:pPr>
-              <a:spcAft>
-                <a:spcPts val="800"/>
-              </a:spcAft>
-              <a:defRPr sz="1300">
-                <a:solidFill>
-                  <a:srgbClr val="262626"/>
-                </a:solidFill>
-                <a:latin typeface="Arial"/>
-              </a:defRPr>
-            </a:pPr>
-            <a:r>
-              <a:t>Domini: Portfolio, Holding, Price, Ticker, ShareQuantity</a:t>
-            </a:r>
-          </a:p>
-        </p:txBody>
-      </p:sp>
-      <p:sp>
-        <p:nvSpPr>
-          <p:cNvPr id="9" name="TextBox 8"/>
-          <p:cNvSpPr txBox="1"/>
-          <p:nvPr/>
-        </p:nvSpPr>
-        <p:spPr>
-          <a:xfrm>
-            <a:off x="8549640" y="5669280"/>
-            <a:ext cx="2743200" cy="228600"/>
-          </a:xfrm>
-          <a:prstGeom prst="rect">
-            <a:avLst/>
-          </a:prstGeom>
-          <a:noFill/>
-        </p:spPr>
-        <p:txBody>
-          <a:bodyPr wrap="square">
-            <a:normAutofit/>
-          </a:bodyPr>
-          <a:lstStyle/>
-          <a:p>
-            <a:pPr algn="ctr"/>
-            <a:r>
-              <a:rPr sz="1000" b="0">
+            <a:pPr algn="l"/>
+            <a:r>
+              <a:rPr sz="800" b="0">
                 <a:solidFill>
                   <a:srgbClr val="66707A"/>
                 </a:solidFill>
                 <a:latin typeface="Arial"/>
               </a:rPr>
-              <a:t>Diagrama del tutorial HexaStock Sell Stocks.</a:t>
+              <a:t>Disseny de Sistemes d'Informació · Ports de sortida en arquitectura hexagonal</a:t>
             </a:r>
           </a:p>
         </p:txBody>
@@ -7775,41 +8266,6 @@
       <p:sp>
         <p:nvSpPr>
           <p:cNvPr id="10" name="TextBox 9"/>
-          <p:cNvSpPr txBox="1"/>
-          <p:nvPr/>
-        </p:nvSpPr>
-        <p:spPr>
-          <a:xfrm>
-            <a:off x="594360" y="6473952"/>
-            <a:ext cx="8595360" cy="201168"/>
-          </a:xfrm>
-          <a:prstGeom prst="rect">
-            <a:avLst/>
-          </a:prstGeom>
-          <a:noFill/>
-        </p:spPr>
-        <p:txBody>
-          <a:bodyPr wrap="square">
-            <a:normAutofit/>
-          </a:bodyPr>
-          <a:lstStyle/>
-          <a:p>
-            <a:pPr algn="l"/>
-            <a:r>
-              <a:rPr sz="800" b="0">
-                <a:solidFill>
-                  <a:srgbClr val="66707A"/>
-                </a:solidFill>
-                <a:latin typeface="Arial"/>
-              </a:rPr>
-              <a:t>Disseny de Sistemes d'Informació · Ports de sortida en arquitectura hexagonal</a:t>
-            </a:r>
-          </a:p>
-        </p:txBody>
-      </p:sp>
-      <p:sp>
-        <p:nvSpPr>
-          <p:cNvPr id="11" name="TextBox 10"/>
           <p:cNvSpPr txBox="1"/>
           <p:nvPr/>
         </p:nvSpPr>
@@ -7897,7 +8353,7 @@
                 </a:solidFill>
                 <a:latin typeface="Arial"/>
               </a:rPr>
-              <a:t>Flux i codi essencial</a:t>
+              <a:t>Transferència a HexaStock</a:t>
             </a:r>
           </a:p>
         </p:txBody>
@@ -7932,7 +8388,7 @@
                 </a:solidFill>
                 <a:latin typeface="Arial"/>
               </a:rPr>
-              <a:t>El servei coordina. El domini decideix. La infraestructura adapta.</a:t>
+              <a:t>Venda d'accions amb proveïdor de preus substituïble</a:t>
             </a:r>
           </a:p>
         </p:txBody>
@@ -8007,7 +8463,7 @@
       </p:sp>
       <p:pic>
         <p:nvPicPr>
-          <p:cNvPr id="6" name="Picture 5" descr="sell-stock-sequence.png"/>
+          <p:cNvPr id="6" name="Picture 5" descr="hexastock-sellstocks-arquitectura-vpd.png"/>
           <p:cNvPicPr>
             <a:picLocks noChangeAspect="1"/>
           </p:cNvPicPr>
@@ -8021,8 +8477,8 @@
         </p:blipFill>
         <p:spPr>
           <a:xfrm>
-            <a:off x="502920" y="1962677"/>
-            <a:ext cx="7315200" cy="3069806"/>
+            <a:off x="502920" y="1600138"/>
+            <a:ext cx="7818120" cy="4389244"/>
           </a:xfrm>
           <a:prstGeom prst="rect">
             <a:avLst/>
@@ -8031,98 +8487,14 @@
       </p:pic>
       <p:sp>
         <p:nvSpPr>
-          <p:cNvPr id="7" name="Rounded Rectangle 6"/>
-          <p:cNvSpPr/>
-          <p:nvPr/>
-        </p:nvSpPr>
-        <p:spPr>
-          <a:xfrm>
-            <a:off x="8092440" y="1645920"/>
-            <a:ext cx="3520440" cy="2423160"/>
-          </a:xfrm>
-          <a:prstGeom prst="roundRect">
-            <a:avLst/>
-          </a:prstGeom>
-          <a:solidFill>
-            <a:srgbClr val="1F2429"/>
-          </a:solidFill>
-          <a:ln>
-            <a:solidFill>
-              <a:srgbClr val="1F2429"/>
-            </a:solidFill>
-          </a:ln>
-        </p:spPr>
-        <p:style>
-          <a:lnRef idx="1">
-            <a:schemeClr val="accent1"/>
-          </a:lnRef>
-          <a:fillRef idx="3">
-            <a:schemeClr val="accent1"/>
-          </a:fillRef>
-          <a:effectRef idx="2">
-            <a:schemeClr val="accent1"/>
-          </a:effectRef>
-          <a:fontRef idx="minor">
-            <a:schemeClr val="lt1"/>
-          </a:fontRef>
-        </p:style>
-        <p:txBody>
-          <a:bodyPr rtlCol="0" anchor="ctr"/>
-          <a:lstStyle/>
-          <a:p>
-            <a:pPr algn="ctr"/>
-            <a:endParaRPr/>
-          </a:p>
-        </p:txBody>
-      </p:sp>
-      <p:sp>
-        <p:nvSpPr>
-          <p:cNvPr id="8" name="TextBox 7"/>
+          <p:cNvPr id="7" name="TextBox 6"/>
           <p:cNvSpPr txBox="1"/>
           <p:nvPr/>
         </p:nvSpPr>
         <p:spPr>
           <a:xfrm>
-            <a:off x="8293608" y="1810512"/>
-            <a:ext cx="3118104" cy="2093976"/>
-          </a:xfrm>
-          <a:prstGeom prst="rect">
-            <a:avLst/>
-          </a:prstGeom>
-          <a:noFill/>
-        </p:spPr>
-        <p:txBody>
-          <a:bodyPr wrap="square">
-            <a:spAutoFit/>
-          </a:bodyPr>
-          <a:lstStyle/>
-          <a:p>
-            <a:r>
-              <a:rPr sz="1500">
-                <a:solidFill>
-                  <a:srgbClr val="F5F6F7"/>
-                </a:solidFill>
-                <a:latin typeface="Consolas"/>
-              </a:rPr>
-              <a:t>StockPrice stockPrice =
-    stockPriceProviderPort.fetchStockPrice(ticker);
-Price price = stockPrice.price();
-SellResult sellResult =
-    portfolio.sell(ticker, quantity, price);</a:t>
-            </a:r>
-          </a:p>
-        </p:txBody>
-      </p:sp>
-      <p:sp>
-        <p:nvSpPr>
-          <p:cNvPr id="9" name="TextBox 8"/>
-          <p:cNvSpPr txBox="1"/>
-          <p:nvPr/>
-        </p:nvSpPr>
-        <p:spPr>
-          <a:xfrm>
-            <a:off x="8138160" y="4434840"/>
-            <a:ext cx="3429000" cy="822960"/>
+            <a:off x="8549640" y="1600200"/>
+            <a:ext cx="2743200" cy="2011680"/>
           </a:xfrm>
           <a:prstGeom prst="rect">
             <a:avLst/>
@@ -8137,13 +8509,119 @@
           <a:p>
             <a:pPr algn="l"/>
             <a:r>
-              <a:rPr sz="1700" b="0">
+              <a:rPr sz="1700" b="1">
                 <a:solidFill>
                   <a:srgbClr val="192D3E"/>
                 </a:solidFill>
                 <a:latin typeface="Arial"/>
               </a:rPr>
-              <a:t>El servei obté informació externa a través d'un port i delega la decisió al domini ric.</a:t>
+              <a:t>El cas d'ús necessita el preu actual d'un ticker, però no ha de dependre de Finnhub, Alpha Vantage, REST, JSON, tokens, endpoints ni clients HTTP.</a:t>
+            </a:r>
+          </a:p>
+        </p:txBody>
+      </p:sp>
+      <p:sp>
+        <p:nvSpPr>
+          <p:cNvPr id="8" name="TextBox 7"/>
+          <p:cNvSpPr txBox="1"/>
+          <p:nvPr/>
+        </p:nvSpPr>
+        <p:spPr>
+          <a:xfrm>
+            <a:off x="8549640" y="3931920"/>
+            <a:ext cx="2743200" cy="1417320"/>
+          </a:xfrm>
+          <a:prstGeom prst="rect">
+            <a:avLst/>
+          </a:prstGeom>
+          <a:noFill/>
+        </p:spPr>
+        <p:txBody>
+          <a:bodyPr wrap="square">
+            <a:normAutofit/>
+          </a:bodyPr>
+          <a:lstStyle/>
+          <a:p>
+            <a:pPr>
+              <a:spcAft>
+                <a:spcPts val="800"/>
+              </a:spcAft>
+              <a:defRPr sz="1300">
+                <a:solidFill>
+                  <a:srgbClr val="262626"/>
+                </a:solidFill>
+                <a:latin typeface="Arial"/>
+              </a:defRPr>
+            </a:pPr>
+            <a:r>
+              <a:t>Port: StockPriceProviderPort</a:t>
+            </a:r>
+          </a:p>
+          <a:p>
+            <a:pPr>
+              <a:spcAft>
+                <a:spcPts val="800"/>
+              </a:spcAft>
+              <a:defRPr sz="1300">
+                <a:solidFill>
+                  <a:srgbClr val="262626"/>
+                </a:solidFill>
+                <a:latin typeface="Arial"/>
+              </a:defRPr>
+            </a:pPr>
+            <a:r>
+              <a:t>Adaptadors: Finnhub, Alpha Vantage, mock</a:t>
+            </a:r>
+          </a:p>
+          <a:p>
+            <a:pPr>
+              <a:spcAft>
+                <a:spcPts val="800"/>
+              </a:spcAft>
+              <a:defRPr sz="1300">
+                <a:solidFill>
+                  <a:srgbClr val="262626"/>
+                </a:solidFill>
+                <a:latin typeface="Arial"/>
+              </a:defRPr>
+            </a:pPr>
+            <a:r>
+              <a:t>Domini: Portfolio, Holding, Price, Ticker, ShareQuantity</a:t>
+            </a:r>
+          </a:p>
+        </p:txBody>
+      </p:sp>
+      <p:sp>
+        <p:nvSpPr>
+          <p:cNvPr id="9" name="TextBox 8"/>
+          <p:cNvSpPr txBox="1"/>
+          <p:nvPr/>
+        </p:nvSpPr>
+        <p:spPr>
+          <a:xfrm>
+            <a:off x="8549640" y="5669280"/>
+            <a:ext cx="2743200" cy="228600"/>
+          </a:xfrm>
+          <a:prstGeom prst="rect">
+            <a:avLst/>
+          </a:prstGeom>
+          <a:noFill/>
+        </p:spPr>
+        <p:txBody>
+          <a:bodyPr wrap="square">
+            <a:normAutofit/>
+          </a:bodyPr>
+          <a:lstStyle/>
+          <a:p>
+            <a:pPr algn="ctr"/>
+            <a:r>
+              <a:rPr sz="1000" b="0">
+                <a:solidFill>
+                  <a:srgbClr val="66707A"/>
+                </a:solidFill>
+                <a:latin typeface="Arial"/>
+              </a:rPr>
+              <a:t>Diagrama del tutorial HexaStock Sell Stocks.</a:t>
             </a:r>
           </a:p>
         </p:txBody>

</xml_diff>